<commit_message>
Add final Run 22 validation and test results
Co-Authored-By: Claude Opus 5.5 <noreply@anthropic.com>
</commit_message>
<xml_diff>
--- a/slides/CIPHER_AI2_Final_Defense.pptx
+++ b/slides/CIPHER_AI2_Final_Defense.pptx
@@ -734,7 +734,7 @@
           <a:lstStyle/>
           <a:p>
             <a:r>
-              <a:t>Rot is easiest. Surface damage is hardest because it is small and low contrast.</a:t>
+              <a:t>Bruise and rot score highest. Surface damage is hardest because it is small and low contrast.</a:t>
             </a:r>
           </a:p>
         </p:txBody>
@@ -6466,7 +6466,7 @@
                           </a:solidFill>
                           <a:latin typeface="Arial"/>
                         </a:rPr>
-                        <a:t>0.458</a:t>
+                        <a:t>0.457</a:t>
                       </a:r>
                     </a:p>
                   </a:txBody>
@@ -6515,7 +6515,7 @@
                 </a:solidFill>
                 <a:latin typeface="Arial"/>
               </a:rPr>
-              <a:t>Runs 14 to 22 still score lower overall than joint runs because they no longer include easy whole-fruit classes in the average. Run 20 and 22 numbers are defects only.</a:t>
+              <a:t>Joint runs average in the easy whole-fruit classes. Runs 20 and 22 report the three defect classes only so their lower number does not mean a worse model.</a:t>
             </a:r>
           </a:p>
         </p:txBody>
@@ -7634,7 +7634,7 @@
                           </a:solidFill>
                           <a:latin typeface="Arial"/>
                         </a:rPr>
-                        <a:t>TBD</a:t>
+                        <a:t>0.847</a:t>
                       </a:r>
                     </a:p>
                   </a:txBody>
@@ -7657,7 +7657,7 @@
                           </a:solidFill>
                           <a:latin typeface="Arial"/>
                         </a:rPr>
-                        <a:t>TBD</a:t>
+                        <a:t>0.744</a:t>
                       </a:r>
                     </a:p>
                   </a:txBody>
@@ -7680,7 +7680,7 @@
                           </a:solidFill>
                           <a:latin typeface="Arial"/>
                         </a:rPr>
-                        <a:t>TBD</a:t>
+                        <a:t>0.777</a:t>
                       </a:r>
                     </a:p>
                   </a:txBody>
@@ -7703,7 +7703,7 @@
                           </a:solidFill>
                           <a:latin typeface="Arial"/>
                         </a:rPr>
-                        <a:t>TBD</a:t>
+                        <a:t>0.526</a:t>
                       </a:r>
                     </a:p>
                   </a:txBody>
@@ -7751,7 +7751,7 @@
                           </a:solidFill>
                           <a:latin typeface="Arial"/>
                         </a:rPr>
-                        <a:t>TBD</a:t>
+                        <a:t>0.931</a:t>
                       </a:r>
                     </a:p>
                   </a:txBody>
@@ -7774,7 +7774,7 @@
                           </a:solidFill>
                           <a:latin typeface="Arial"/>
                         </a:rPr>
-                        <a:t>TBD</a:t>
+                        <a:t>0.713</a:t>
                       </a:r>
                     </a:p>
                   </a:txBody>
@@ -7797,7 +7797,7 @@
                           </a:solidFill>
                           <a:latin typeface="Arial"/>
                         </a:rPr>
-                        <a:t>TBD</a:t>
+                        <a:t>0.761</a:t>
                       </a:r>
                     </a:p>
                   </a:txBody>
@@ -7820,7 +7820,7 @@
                           </a:solidFill>
                           <a:latin typeface="Arial"/>
                         </a:rPr>
-                        <a:t>TBD</a:t>
+                        <a:t>0.591</a:t>
                       </a:r>
                     </a:p>
                   </a:txBody>
@@ -7868,7 +7868,7 @@
                           </a:solidFill>
                           <a:latin typeface="Arial"/>
                         </a:rPr>
-                        <a:t>TBD</a:t>
+                        <a:t>0.648</a:t>
                       </a:r>
                     </a:p>
                   </a:txBody>
@@ -7891,7 +7891,7 @@
                           </a:solidFill>
                           <a:latin typeface="Arial"/>
                         </a:rPr>
-                        <a:t>TBD</a:t>
+                        <a:t>0.584</a:t>
                       </a:r>
                     </a:p>
                   </a:txBody>
@@ -7914,7 +7914,7 @@
                           </a:solidFill>
                           <a:latin typeface="Arial"/>
                         </a:rPr>
-                        <a:t>TBD</a:t>
+                        <a:t>0.527</a:t>
                       </a:r>
                     </a:p>
                   </a:txBody>
@@ -7937,7 +7937,7 @@
                           </a:solidFill>
                           <a:latin typeface="Arial"/>
                         </a:rPr>
-                        <a:t>TBD</a:t>
+                        <a:t>0.253</a:t>
                       </a:r>
                     </a:p>
                   </a:txBody>
@@ -7985,7 +7985,7 @@
                           </a:solidFill>
                           <a:latin typeface="Arial"/>
                         </a:rPr>
-                        <a:t>0.785</a:t>
+                        <a:t>0.809</a:t>
                       </a:r>
                     </a:p>
                   </a:txBody>
@@ -8008,7 +8008,7 @@
                           </a:solidFill>
                           <a:latin typeface="Arial"/>
                         </a:rPr>
-                        <a:t>0.645</a:t>
+                        <a:t>0.680</a:t>
                       </a:r>
                     </a:p>
                   </a:txBody>
@@ -8054,7 +8054,7 @@
                           </a:solidFill>
                           <a:latin typeface="Arial"/>
                         </a:rPr>
-                        <a:t>0.458</a:t>
+                        <a:t>0.457</a:t>
                       </a:r>
                     </a:p>
                   </a:txBody>
@@ -8069,60 +8069,30 @@
           </a:graphicData>
         </a:graphic>
       </p:graphicFrame>
-      <p:sp>
-        <p:nvSpPr>
-          <p:cNvPr id="7" name="Rectangle 6"/>
-          <p:cNvSpPr/>
+      <p:pic>
+        <p:nvPicPr>
+          <p:cNvPr id="7" name="Picture 6" descr="MaskPR_curve.png"/>
+          <p:cNvPicPr>
+            <a:picLocks noChangeAspect="1"/>
+          </p:cNvPicPr>
           <p:nvPr/>
-        </p:nvSpPr>
+        </p:nvPicPr>
+        <p:blipFill>
+          <a:blip r:embed="rId3"/>
+          <a:stretch>
+            <a:fillRect/>
+          </a:stretch>
+        </p:blipFill>
         <p:spPr>
           <a:xfrm>
-            <a:off x="6400800" y="1371600"/>
-            <a:ext cx="5303520" cy="4754880"/>
+            <a:off x="6400800" y="1981200"/>
+            <a:ext cx="5303520" cy="3535680"/>
           </a:xfrm>
           <a:prstGeom prst="rect">
             <a:avLst/>
           </a:prstGeom>
-          <a:solidFill>
-            <a:srgbClr val="F5F7FA"/>
-          </a:solidFill>
-          <a:ln>
-            <a:solidFill>
-              <a:srgbClr val="CBD2D9"/>
-            </a:solidFill>
-          </a:ln>
         </p:spPr>
-        <p:style>
-          <a:lnRef idx="1">
-            <a:schemeClr val="accent1"/>
-          </a:lnRef>
-          <a:fillRef idx="3">
-            <a:schemeClr val="accent1"/>
-          </a:fillRef>
-          <a:effectRef idx="2">
-            <a:schemeClr val="accent1"/>
-          </a:effectRef>
-          <a:fontRef idx="minor">
-            <a:schemeClr val="lt1"/>
-          </a:fontRef>
-        </p:style>
-        <p:txBody>
-          <a:bodyPr rtlCol="0" anchor="ctr"/>
-          <a:lstStyle/>
-          <a:p>
-            <a:pPr algn="ctr"/>
-            <a:r>
-              <a:rPr sz="1400">
-                <a:solidFill>
-                  <a:srgbClr val="52606D"/>
-                </a:solidFill>
-                <a:latin typeface="Arial"/>
-              </a:rPr>
-              <a:t>Pending: Run 22 mask PR curve</a:t>
-            </a:r>
-          </a:p>
-        </p:txBody>
-      </p:sp>
+      </p:pic>
     </p:spTree>
   </p:cSld>
   <p:clrMapOvr>
@@ -8175,7 +8145,7 @@
                 </a:solidFill>
                 <a:latin typeface="Arial"/>
               </a:rPr>
-              <a:t>Confusion matrix (validation)</a:t>
+              <a:t>Confusion matrices</a:t>
             </a:r>
           </a:p>
         </p:txBody>
@@ -8301,70 +8271,64 @@
           </a:p>
         </p:txBody>
       </p:sp>
-      <p:sp>
-        <p:nvSpPr>
-          <p:cNvPr id="6" name="Rectangle 5"/>
-          <p:cNvSpPr/>
+      <p:pic>
+        <p:nvPicPr>
+          <p:cNvPr id="6" name="Picture 5" descr="confusion_matrix_normalized.png"/>
+          <p:cNvPicPr>
+            <a:picLocks noChangeAspect="1"/>
+          </p:cNvPicPr>
           <p:nvPr/>
-        </p:nvSpPr>
+        </p:nvPicPr>
+        <p:blipFill>
+          <a:blip r:embed="rId3"/>
+          <a:stretch>
+            <a:fillRect/>
+          </a:stretch>
+        </p:blipFill>
         <p:spPr>
           <a:xfrm>
-            <a:off x="548640" y="1280160"/>
-            <a:ext cx="6400800" cy="4937760"/>
+            <a:off x="518160" y="1280160"/>
+            <a:ext cx="5364480" cy="4023360"/>
           </a:xfrm>
           <a:prstGeom prst="rect">
             <a:avLst/>
           </a:prstGeom>
-          <a:solidFill>
-            <a:srgbClr val="F5F7FA"/>
-          </a:solidFill>
-          <a:ln>
-            <a:solidFill>
-              <a:srgbClr val="CBD2D9"/>
-            </a:solidFill>
-          </a:ln>
         </p:spPr>
-        <p:style>
-          <a:lnRef idx="1">
-            <a:schemeClr val="accent1"/>
-          </a:lnRef>
-          <a:fillRef idx="3">
-            <a:schemeClr val="accent1"/>
-          </a:fillRef>
-          <a:effectRef idx="2">
-            <a:schemeClr val="accent1"/>
-          </a:effectRef>
-          <a:fontRef idx="minor">
-            <a:schemeClr val="lt1"/>
-          </a:fontRef>
-        </p:style>
-        <p:txBody>
-          <a:bodyPr rtlCol="0" anchor="ctr"/>
-          <a:lstStyle/>
-          <a:p>
-            <a:pPr algn="ctr"/>
-            <a:r>
-              <a:rPr sz="1400">
-                <a:solidFill>
-                  <a:srgbClr val="52606D"/>
-                </a:solidFill>
-                <a:latin typeface="Arial"/>
-              </a:rPr>
-              <a:t>Pending: Run 22 confusion_matrix_normalized.png</a:t>
-            </a:r>
-          </a:p>
-        </p:txBody>
-      </p:sp>
-      <p:sp>
-        <p:nvSpPr>
-          <p:cNvPr id="7" name="TextBox 6"/>
+      </p:pic>
+      <p:pic>
+        <p:nvPicPr>
+          <p:cNvPr id="7" name="Picture 6" descr="confusion_matrix_normalized.png"/>
+          <p:cNvPicPr>
+            <a:picLocks noChangeAspect="1"/>
+          </p:cNvPicPr>
+          <p:nvPr/>
+        </p:nvPicPr>
+        <p:blipFill>
+          <a:blip r:embed="rId4"/>
+          <a:stretch>
+            <a:fillRect/>
+          </a:stretch>
+        </p:blipFill>
+        <p:spPr>
+          <a:xfrm>
+            <a:off x="6278880" y="1280160"/>
+            <a:ext cx="5364480" cy="4023360"/>
+          </a:xfrm>
+          <a:prstGeom prst="rect">
+            <a:avLst/>
+          </a:prstGeom>
+        </p:spPr>
+      </p:pic>
+      <p:sp>
+        <p:nvSpPr>
+          <p:cNvPr id="8" name="TextBox 7"/>
           <p:cNvSpPr txBox="1"/>
           <p:nvPr/>
         </p:nvSpPr>
         <p:spPr>
           <a:xfrm>
-            <a:off x="7315200" y="1554480"/>
-            <a:ext cx="4389120" cy="4389120"/>
+            <a:off x="548640" y="5303520"/>
+            <a:ext cx="5486400" cy="365760"/>
           </a:xfrm>
           <a:prstGeom prst="rect">
             <a:avLst/>
@@ -8377,67 +8341,97 @@
           </a:bodyPr>
           <a:lstStyle/>
           <a:p>
+            <a:pPr algn="ctr">
+              <a:spcAft>
+                <a:spcPts val="800"/>
+              </a:spcAft>
+            </a:pPr>
+            <a:r>
+              <a:rPr sz="1300" b="0">
+                <a:solidFill>
+                  <a:srgbClr val="52606D"/>
+                </a:solidFill>
+                <a:latin typeface="Arial"/>
+              </a:rPr>
+              <a:t>Validation (215 images)</a:t>
+            </a:r>
+          </a:p>
+        </p:txBody>
+      </p:sp>
+      <p:sp>
+        <p:nvSpPr>
+          <p:cNvPr id="9" name="TextBox 8"/>
+          <p:cNvSpPr txBox="1"/>
+          <p:nvPr/>
+        </p:nvSpPr>
+        <p:spPr>
+          <a:xfrm>
+            <a:off x="6309360" y="5303520"/>
+            <a:ext cx="5486400" cy="365760"/>
+          </a:xfrm>
+          <a:prstGeom prst="rect">
+            <a:avLst/>
+          </a:prstGeom>
+          <a:noFill/>
+        </p:spPr>
+        <p:txBody>
+          <a:bodyPr wrap="square" anchor="t">
+            <a:spAutoFit/>
+          </a:bodyPr>
+          <a:lstStyle/>
+          <a:p>
+            <a:pPr algn="ctr">
+              <a:spcAft>
+                <a:spcPts val="800"/>
+              </a:spcAft>
+            </a:pPr>
+            <a:r>
+              <a:rPr sz="1300" b="0">
+                <a:solidFill>
+                  <a:srgbClr val="52606D"/>
+                </a:solidFill>
+                <a:latin typeface="Arial"/>
+              </a:rPr>
+              <a:t>Unseen test (79 images)</a:t>
+            </a:r>
+          </a:p>
+        </p:txBody>
+      </p:sp>
+      <p:sp>
+        <p:nvSpPr>
+          <p:cNvPr id="10" name="TextBox 9"/>
+          <p:cNvSpPr txBox="1"/>
+          <p:nvPr/>
+        </p:nvSpPr>
+        <p:spPr>
+          <a:xfrm>
+            <a:off x="548640" y="5669280"/>
+            <a:ext cx="11155680" cy="731520"/>
+          </a:xfrm>
+          <a:prstGeom prst="rect">
+            <a:avLst/>
+          </a:prstGeom>
+          <a:noFill/>
+        </p:spPr>
+        <p:txBody>
+          <a:bodyPr wrap="square" anchor="t">
+            <a:spAutoFit/>
+          </a:bodyPr>
+          <a:lstStyle/>
+          <a:p>
             <a:pPr algn="l">
               <a:spcAft>
                 <a:spcPts val="800"/>
               </a:spcAft>
             </a:pPr>
             <a:r>
-              <a:rPr sz="1600" b="0">
+              <a:rPr sz="1300" b="0">
                 <a:solidFill>
                   <a:srgbClr val="1F2933"/>
                 </a:solidFill>
                 <a:latin typeface="Arial"/>
               </a:rPr>
-              <a:t>•  Columns are true classes and rows are predictions</a:t>
-            </a:r>
-          </a:p>
-          <a:p>
-            <a:pPr algn="l">
-              <a:spcAft>
-                <a:spcPts val="800"/>
-              </a:spcAft>
-            </a:pPr>
-            <a:r>
-              <a:rPr sz="1600" b="0">
-                <a:solidFill>
-                  <a:srgbClr val="1F2933"/>
-                </a:solidFill>
-                <a:latin typeface="Arial"/>
-              </a:rPr>
-              <a:t>•  Largest error: defects missed as background</a:t>
-            </a:r>
-          </a:p>
-          <a:p>
-            <a:pPr algn="l">
-              <a:spcAft>
-                <a:spcPts val="800"/>
-              </a:spcAft>
-            </a:pPr>
-            <a:r>
-              <a:rPr sz="1600" b="0">
-                <a:solidFill>
-                  <a:srgbClr val="1F2933"/>
-                </a:solidFill>
-                <a:latin typeface="Arial"/>
-              </a:rPr>
-              <a:t>•  Some bruise and rot confusion where early rot looks like a bruise</a:t>
-            </a:r>
-          </a:p>
-          <a:p>
-            <a:pPr algn="l">
-              <a:spcAft>
-                <a:spcPts val="800"/>
-              </a:spcAft>
-            </a:pPr>
-            <a:r>
-              <a:rPr sz="1600" b="0">
-                <a:solidFill>
-                  <a:srgbClr val="1F2933"/>
-                </a:solidFill>
-                <a:latin typeface="Arial"/>
-              </a:rPr>
-              <a:t>•  Few false alarms on healthy skin</a:t>
+              <a:t>Columns are true classes. Main error: defects missed as background. Bruise and rot rarely confused (4% or less). Validation false alarms are mostly surface damage.</a:t>
             </a:r>
           </a:p>
         </p:txBody>
@@ -8620,60 +8614,30 @@
           </a:p>
         </p:txBody>
       </p:sp>
-      <p:sp>
-        <p:nvSpPr>
-          <p:cNvPr id="6" name="Rectangle 5"/>
-          <p:cNvSpPr/>
+      <p:pic>
+        <p:nvPicPr>
+          <p:cNvPr id="6" name="Picture 5" descr="results.png"/>
+          <p:cNvPicPr>
+            <a:picLocks noChangeAspect="1"/>
+          </p:cNvPicPr>
           <p:nvPr/>
-        </p:nvSpPr>
+        </p:nvPicPr>
+        <p:blipFill>
+          <a:blip r:embed="rId3"/>
+          <a:stretch>
+            <a:fillRect/>
+          </a:stretch>
+        </p:blipFill>
         <p:spPr>
           <a:xfrm>
-            <a:off x="548640" y="1280160"/>
-            <a:ext cx="11064240" cy="5029200"/>
+            <a:off x="548640" y="2135124"/>
+            <a:ext cx="11064240" cy="3319272"/>
           </a:xfrm>
           <a:prstGeom prst="rect">
             <a:avLst/>
           </a:prstGeom>
-          <a:solidFill>
-            <a:srgbClr val="F5F7FA"/>
-          </a:solidFill>
-          <a:ln>
-            <a:solidFill>
-              <a:srgbClr val="CBD2D9"/>
-            </a:solidFill>
-          </a:ln>
         </p:spPr>
-        <p:style>
-          <a:lnRef idx="1">
-            <a:schemeClr val="accent1"/>
-          </a:lnRef>
-          <a:fillRef idx="3">
-            <a:schemeClr val="accent1"/>
-          </a:fillRef>
-          <a:effectRef idx="2">
-            <a:schemeClr val="accent1"/>
-          </a:effectRef>
-          <a:fontRef idx="minor">
-            <a:schemeClr val="lt1"/>
-          </a:fontRef>
-        </p:style>
-        <p:txBody>
-          <a:bodyPr rtlCol="0" anchor="ctr"/>
-          <a:lstStyle/>
-          <a:p>
-            <a:pPr algn="ctr"/>
-            <a:r>
-              <a:rPr sz="1400">
-                <a:solidFill>
-                  <a:srgbClr val="52606D"/>
-                </a:solidFill>
-                <a:latin typeface="Arial"/>
-              </a:rPr>
-              <a:t>Pending: Run 22 results.png</a:t>
-            </a:r>
-          </a:p>
-        </p:txBody>
-      </p:sp>
+      </p:pic>
     </p:spTree>
   </p:cSld>
   <p:clrMapOvr>
@@ -8983,7 +8947,7 @@
                           </a:solidFill>
                           <a:latin typeface="Arial"/>
                         </a:rPr>
-                        <a:t>0.785</a:t>
+                        <a:t>0.809</a:t>
                       </a:r>
                     </a:p>
                   </a:txBody>
@@ -9006,7 +8970,7 @@
                           </a:solidFill>
                           <a:latin typeface="Arial"/>
                         </a:rPr>
-                        <a:t>TBD</a:t>
+                        <a:t>0.718</a:t>
                       </a:r>
                     </a:p>
                   </a:txBody>
@@ -9054,7 +9018,7 @@
                           </a:solidFill>
                           <a:latin typeface="Arial"/>
                         </a:rPr>
-                        <a:t>0.645</a:t>
+                        <a:t>0.680</a:t>
                       </a:r>
                     </a:p>
                   </a:txBody>
@@ -9077,7 +9041,7 @@
                           </a:solidFill>
                           <a:latin typeface="Arial"/>
                         </a:rPr>
-                        <a:t>TBD</a:t>
+                        <a:t>0.597</a:t>
                       </a:r>
                     </a:p>
                   </a:txBody>
@@ -9148,7 +9112,7 @@
                           </a:solidFill>
                           <a:latin typeface="Arial"/>
                         </a:rPr>
-                        <a:t>TBD</a:t>
+                        <a:t>0.613</a:t>
                       </a:r>
                     </a:p>
                   </a:txBody>
@@ -9196,7 +9160,7 @@
                           </a:solidFill>
                           <a:latin typeface="Arial"/>
                         </a:rPr>
-                        <a:t>0.458</a:t>
+                        <a:t>0.457</a:t>
                       </a:r>
                     </a:p>
                   </a:txBody>
@@ -9219,7 +9183,7 @@
                           </a:solidFill>
                           <a:latin typeface="Arial"/>
                         </a:rPr>
-                        <a:t>TBD</a:t>
+                        <a:t>0.411</a:t>
                       </a:r>
                     </a:p>
                   </a:txBody>
@@ -9234,9 +9198,320 @@
           </a:graphicData>
         </a:graphic>
       </p:graphicFrame>
-      <p:sp>
-        <p:nvSpPr>
-          <p:cNvPr id="7" name="TextBox 6"/>
+      <p:graphicFrame>
+        <p:nvGraphicFramePr>
+          <p:cNvPr id="7" name="Table 6"/>
+          <p:cNvGraphicFramePr>
+            <a:graphicFrameLocks noGrp="1"/>
+          </p:cNvGraphicFramePr>
+          <p:nvPr/>
+        </p:nvGraphicFramePr>
+        <p:xfrm>
+          <a:off x="548640" y="3749039"/>
+          <a:ext cx="6400800" cy="1536192"/>
+        </p:xfrm>
+        <a:graphic>
+          <a:graphicData uri="http://schemas.openxmlformats.org/drawingml/2006/table">
+            <a:tbl>
+              <a:tblPr firstRow="1" bandRow="1">
+                <a:tableStyleId>{5C22544A-7EE6-4342-B048-85BDC9FD1C3A}</a:tableStyleId>
+              </a:tblPr>
+              <a:tblGrid>
+                <a:gridCol w="2194560"/>
+                <a:gridCol w="2011680"/>
+                <a:gridCol w="2194560"/>
+              </a:tblGrid>
+              <a:tr h="384048">
+                <a:tc>
+                  <a:txBody>
+                    <a:bodyPr/>
+                    <a:lstStyle/>
+                    <a:p>
+                      <a:pPr algn="l"/>
+                      <a:r>
+                        <a:rPr sz="1300" b="1">
+                          <a:solidFill>
+                            <a:srgbClr val="FFFFFF"/>
+                          </a:solidFill>
+                          <a:latin typeface="Arial"/>
+                        </a:rPr>
+                        <a:t>Class</a:t>
+                      </a:r>
+                    </a:p>
+                  </a:txBody>
+                  <a:tcPr>
+                    <a:solidFill>
+                      <a:srgbClr val="1F2933"/>
+                    </a:solidFill>
+                  </a:tcPr>
+                </a:tc>
+                <a:tc>
+                  <a:txBody>
+                    <a:bodyPr/>
+                    <a:lstStyle/>
+                    <a:p>
+                      <a:pPr algn="ctr"/>
+                      <a:r>
+                        <a:rPr sz="1300" b="1">
+                          <a:solidFill>
+                            <a:srgbClr val="FFFFFF"/>
+                          </a:solidFill>
+                          <a:latin typeface="Arial"/>
+                        </a:rPr>
+                        <a:t>Val mAP50</a:t>
+                      </a:r>
+                    </a:p>
+                  </a:txBody>
+                  <a:tcPr>
+                    <a:solidFill>
+                      <a:srgbClr val="1F2933"/>
+                    </a:solidFill>
+                  </a:tcPr>
+                </a:tc>
+                <a:tc>
+                  <a:txBody>
+                    <a:bodyPr/>
+                    <a:lstStyle/>
+                    <a:p>
+                      <a:pPr algn="ctr"/>
+                      <a:r>
+                        <a:rPr sz="1300" b="1">
+                          <a:solidFill>
+                            <a:srgbClr val="FFFFFF"/>
+                          </a:solidFill>
+                          <a:latin typeface="Arial"/>
+                        </a:rPr>
+                        <a:t>Test mAP50</a:t>
+                      </a:r>
+                    </a:p>
+                  </a:txBody>
+                  <a:tcPr>
+                    <a:solidFill>
+                      <a:srgbClr val="1F2933"/>
+                    </a:solidFill>
+                  </a:tcPr>
+                </a:tc>
+              </a:tr>
+              <a:tr h="384048">
+                <a:tc>
+                  <a:txBody>
+                    <a:bodyPr/>
+                    <a:lstStyle/>
+                    <a:p>
+                      <a:pPr algn="l"/>
+                      <a:r>
+                        <a:rPr sz="1300" b="0">
+                          <a:solidFill>
+                            <a:srgbClr val="1F2933"/>
+                          </a:solidFill>
+                          <a:latin typeface="Arial"/>
+                        </a:rPr>
+                        <a:t>Bruise</a:t>
+                      </a:r>
+                    </a:p>
+                  </a:txBody>
+                  <a:tcPr>
+                    <a:solidFill>
+                      <a:srgbClr val="FFFFFF"/>
+                    </a:solidFill>
+                  </a:tcPr>
+                </a:tc>
+                <a:tc>
+                  <a:txBody>
+                    <a:bodyPr/>
+                    <a:lstStyle/>
+                    <a:p>
+                      <a:pPr algn="ctr"/>
+                      <a:r>
+                        <a:rPr sz="1300" b="0">
+                          <a:solidFill>
+                            <a:srgbClr val="1F2933"/>
+                          </a:solidFill>
+                          <a:latin typeface="Arial"/>
+                        </a:rPr>
+                        <a:t>0.777</a:t>
+                      </a:r>
+                    </a:p>
+                  </a:txBody>
+                  <a:tcPr>
+                    <a:solidFill>
+                      <a:srgbClr val="FFFFFF"/>
+                    </a:solidFill>
+                  </a:tcPr>
+                </a:tc>
+                <a:tc>
+                  <a:txBody>
+                    <a:bodyPr/>
+                    <a:lstStyle/>
+                    <a:p>
+                      <a:pPr algn="ctr"/>
+                      <a:r>
+                        <a:rPr sz="1300" b="0">
+                          <a:solidFill>
+                            <a:srgbClr val="1F2933"/>
+                          </a:solidFill>
+                          <a:latin typeface="Arial"/>
+                        </a:rPr>
+                        <a:t>0.594</a:t>
+                      </a:r>
+                    </a:p>
+                  </a:txBody>
+                  <a:tcPr>
+                    <a:solidFill>
+                      <a:srgbClr val="FFFFFF"/>
+                    </a:solidFill>
+                  </a:tcPr>
+                </a:tc>
+              </a:tr>
+              <a:tr h="384048">
+                <a:tc>
+                  <a:txBody>
+                    <a:bodyPr/>
+                    <a:lstStyle/>
+                    <a:p>
+                      <a:pPr algn="l"/>
+                      <a:r>
+                        <a:rPr sz="1300" b="0">
+                          <a:solidFill>
+                            <a:srgbClr val="1F2933"/>
+                          </a:solidFill>
+                          <a:latin typeface="Arial"/>
+                        </a:rPr>
+                        <a:t>Rot</a:t>
+                      </a:r>
+                    </a:p>
+                  </a:txBody>
+                  <a:tcPr>
+                    <a:solidFill>
+                      <a:srgbClr val="F5F7FA"/>
+                    </a:solidFill>
+                  </a:tcPr>
+                </a:tc>
+                <a:tc>
+                  <a:txBody>
+                    <a:bodyPr/>
+                    <a:lstStyle/>
+                    <a:p>
+                      <a:pPr algn="ctr"/>
+                      <a:r>
+                        <a:rPr sz="1300" b="0">
+                          <a:solidFill>
+                            <a:srgbClr val="1F2933"/>
+                          </a:solidFill>
+                          <a:latin typeface="Arial"/>
+                        </a:rPr>
+                        <a:t>0.761</a:t>
+                      </a:r>
+                    </a:p>
+                  </a:txBody>
+                  <a:tcPr>
+                    <a:solidFill>
+                      <a:srgbClr val="F5F7FA"/>
+                    </a:solidFill>
+                  </a:tcPr>
+                </a:tc>
+                <a:tc>
+                  <a:txBody>
+                    <a:bodyPr/>
+                    <a:lstStyle/>
+                    <a:p>
+                      <a:pPr algn="ctr"/>
+                      <a:r>
+                        <a:rPr sz="1300" b="0">
+                          <a:solidFill>
+                            <a:srgbClr val="1F2933"/>
+                          </a:solidFill>
+                          <a:latin typeface="Arial"/>
+                        </a:rPr>
+                        <a:t>0.732</a:t>
+                      </a:r>
+                    </a:p>
+                  </a:txBody>
+                  <a:tcPr>
+                    <a:solidFill>
+                      <a:srgbClr val="F5F7FA"/>
+                    </a:solidFill>
+                  </a:tcPr>
+                </a:tc>
+              </a:tr>
+              <a:tr h="384048">
+                <a:tc>
+                  <a:txBody>
+                    <a:bodyPr/>
+                    <a:lstStyle/>
+                    <a:p>
+                      <a:pPr algn="l"/>
+                      <a:r>
+                        <a:rPr sz="1300" b="0">
+                          <a:solidFill>
+                            <a:srgbClr val="1F2933"/>
+                          </a:solidFill>
+                          <a:latin typeface="Arial"/>
+                        </a:rPr>
+                        <a:t>Surface</a:t>
+                      </a:r>
+                    </a:p>
+                  </a:txBody>
+                  <a:tcPr>
+                    <a:solidFill>
+                      <a:srgbClr val="FFFFFF"/>
+                    </a:solidFill>
+                  </a:tcPr>
+                </a:tc>
+                <a:tc>
+                  <a:txBody>
+                    <a:bodyPr/>
+                    <a:lstStyle/>
+                    <a:p>
+                      <a:pPr algn="ctr"/>
+                      <a:r>
+                        <a:rPr sz="1300" b="0">
+                          <a:solidFill>
+                            <a:srgbClr val="1F2933"/>
+                          </a:solidFill>
+                          <a:latin typeface="Arial"/>
+                        </a:rPr>
+                        <a:t>0.527</a:t>
+                      </a:r>
+                    </a:p>
+                  </a:txBody>
+                  <a:tcPr>
+                    <a:solidFill>
+                      <a:srgbClr val="FFFFFF"/>
+                    </a:solidFill>
+                  </a:tcPr>
+                </a:tc>
+                <a:tc>
+                  <a:txBody>
+                    <a:bodyPr/>
+                    <a:lstStyle/>
+                    <a:p>
+                      <a:pPr algn="ctr"/>
+                      <a:r>
+                        <a:rPr sz="1300" b="0">
+                          <a:solidFill>
+                            <a:srgbClr val="1F2933"/>
+                          </a:solidFill>
+                          <a:latin typeface="Arial"/>
+                        </a:rPr>
+                        <a:t>0.511</a:t>
+                      </a:r>
+                    </a:p>
+                  </a:txBody>
+                  <a:tcPr>
+                    <a:solidFill>
+                      <a:srgbClr val="FFFFFF"/>
+                    </a:solidFill>
+                  </a:tcPr>
+                </a:tc>
+              </a:tr>
+            </a:tbl>
+          </a:graphicData>
+        </a:graphic>
+      </p:graphicFrame>
+      <p:sp>
+        <p:nvSpPr>
+          <p:cNvPr id="8" name="TextBox 7"/>
           <p:cNvSpPr txBox="1"/>
           <p:nvPr/>
         </p:nvSpPr>
@@ -9262,13 +9537,13 @@
               </a:spcAft>
             </a:pPr>
             <a:r>
-              <a:rPr sz="1600" b="0">
+              <a:rPr sz="1500" b="0">
                 <a:solidFill>
                   <a:srgbClr val="1F2933"/>
                 </a:solidFill>
                 <a:latin typeface="Arial"/>
               </a:rPr>
-              <a:t>•  Test split frozen before training</a:t>
+              <a:t>•  Test frozen before training and used once</a:t>
             </a:r>
           </a:p>
           <a:p>
@@ -9278,13 +9553,13 @@
               </a:spcAft>
             </a:pPr>
             <a:r>
-              <a:rPr sz="1600" b="0">
+              <a:rPr sz="1500" b="0">
                 <a:solidFill>
                   <a:srgbClr val="1F2933"/>
                 </a:solidFill>
                 <a:latin typeface="Arial"/>
               </a:rPr>
-              <a:t>•  No capture group shared with train or validation</a:t>
+              <a:t>•  Drop vs validation is expected: checkpoint was picked on validation</a:t>
             </a:r>
           </a:p>
           <a:p>
@@ -9294,13 +9569,13 @@
               </a:spcAft>
             </a:pPr>
             <a:r>
-              <a:rPr sz="1600" b="0">
+              <a:rPr sz="1500" b="0">
                 <a:solidFill>
                   <a:srgbClr val="1F2933"/>
                 </a:solidFill>
                 <a:latin typeface="Arial"/>
               </a:rPr>
-              <a:t>•  Evaluated once after every choice was frozen</a:t>
+              <a:t>•  Almost all of the drop is bruise</a:t>
             </a:r>
           </a:p>
           <a:p>
@@ -9310,13 +9585,29 @@
               </a:spcAft>
             </a:pPr>
             <a:r>
-              <a:rPr sz="1600" b="0">
+              <a:rPr sz="1500" b="0">
                 <a:solidFill>
                   <a:srgbClr val="1F2933"/>
                 </a:solidFill>
                 <a:latin typeface="Arial"/>
               </a:rPr>
-              <a:t>•  Reserve split of 63 images still untouched</a:t>
+              <a:t>•  Rot and surface damage hold steady</a:t>
+            </a:r>
+          </a:p>
+          <a:p>
+            <a:pPr algn="l">
+              <a:spcAft>
+                <a:spcPts val="800"/>
+              </a:spcAft>
+            </a:pPr>
+            <a:r>
+              <a:rPr sz="1500" b="0">
+                <a:solidFill>
+                  <a:srgbClr val="1F2933"/>
+                </a:solidFill>
+                <a:latin typeface="Arial"/>
+              </a:rPr>
+              <a:t>•  Small test set: one bruise miss moves recall about 4 points</a:t>
             </a:r>
           </a:p>
         </p:txBody>
@@ -10146,114 +10437,54 @@
           </a:p>
         </p:txBody>
       </p:sp>
-      <p:sp>
-        <p:nvSpPr>
-          <p:cNvPr id="6" name="Rectangle 5"/>
-          <p:cNvSpPr/>
+      <p:pic>
+        <p:nvPicPr>
+          <p:cNvPr id="6" name="Picture 5" descr="val_batch0_labels.jpg"/>
+          <p:cNvPicPr>
+            <a:picLocks noChangeAspect="1"/>
+          </p:cNvPicPr>
           <p:nvPr/>
-        </p:nvSpPr>
+        </p:nvPicPr>
+        <p:blipFill>
+          <a:blip r:embed="rId3"/>
+          <a:stretch>
+            <a:fillRect/>
+          </a:stretch>
+        </p:blipFill>
         <p:spPr>
           <a:xfrm>
-            <a:off x="548640" y="1280160"/>
-            <a:ext cx="5486400" cy="4846320"/>
+            <a:off x="548640" y="1645920"/>
+            <a:ext cx="5486400" cy="4114800"/>
           </a:xfrm>
           <a:prstGeom prst="rect">
             <a:avLst/>
           </a:prstGeom>
-          <a:solidFill>
-            <a:srgbClr val="F5F7FA"/>
-          </a:solidFill>
-          <a:ln>
-            <a:solidFill>
-              <a:srgbClr val="CBD2D9"/>
-            </a:solidFill>
-          </a:ln>
         </p:spPr>
-        <p:style>
-          <a:lnRef idx="1">
-            <a:schemeClr val="accent1"/>
-          </a:lnRef>
-          <a:fillRef idx="3">
-            <a:schemeClr val="accent1"/>
-          </a:fillRef>
-          <a:effectRef idx="2">
-            <a:schemeClr val="accent1"/>
-          </a:effectRef>
-          <a:fontRef idx="minor">
-            <a:schemeClr val="lt1"/>
-          </a:fontRef>
-        </p:style>
-        <p:txBody>
-          <a:bodyPr rtlCol="0" anchor="ctr"/>
-          <a:lstStyle/>
-          <a:p>
-            <a:pPr algn="ctr"/>
-            <a:r>
-              <a:rPr sz="1400">
-                <a:solidFill>
-                  <a:srgbClr val="52606D"/>
-                </a:solidFill>
-                <a:latin typeface="Arial"/>
-              </a:rPr>
-              <a:t>Pending: Run 22 val_batch0_labels.jpg</a:t>
-            </a:r>
-          </a:p>
-        </p:txBody>
-      </p:sp>
-      <p:sp>
-        <p:nvSpPr>
-          <p:cNvPr id="7" name="Rectangle 6"/>
-          <p:cNvSpPr/>
+      </p:pic>
+      <p:pic>
+        <p:nvPicPr>
+          <p:cNvPr id="7" name="Picture 6" descr="val_batch0_pred.jpg"/>
+          <p:cNvPicPr>
+            <a:picLocks noChangeAspect="1"/>
+          </p:cNvPicPr>
           <p:nvPr/>
-        </p:nvSpPr>
+        </p:nvPicPr>
+        <p:blipFill>
+          <a:blip r:embed="rId4"/>
+          <a:stretch>
+            <a:fillRect/>
+          </a:stretch>
+        </p:blipFill>
         <p:spPr>
           <a:xfrm>
-            <a:off x="6217920" y="1280160"/>
-            <a:ext cx="5486400" cy="4846320"/>
+            <a:off x="6217920" y="1645920"/>
+            <a:ext cx="5486400" cy="4114800"/>
           </a:xfrm>
           <a:prstGeom prst="rect">
             <a:avLst/>
           </a:prstGeom>
-          <a:solidFill>
-            <a:srgbClr val="F5F7FA"/>
-          </a:solidFill>
-          <a:ln>
-            <a:solidFill>
-              <a:srgbClr val="CBD2D9"/>
-            </a:solidFill>
-          </a:ln>
         </p:spPr>
-        <p:style>
-          <a:lnRef idx="1">
-            <a:schemeClr val="accent1"/>
-          </a:lnRef>
-          <a:fillRef idx="3">
-            <a:schemeClr val="accent1"/>
-          </a:fillRef>
-          <a:effectRef idx="2">
-            <a:schemeClr val="accent1"/>
-          </a:effectRef>
-          <a:fontRef idx="minor">
-            <a:schemeClr val="lt1"/>
-          </a:fontRef>
-        </p:style>
-        <p:txBody>
-          <a:bodyPr rtlCol="0" anchor="ctr"/>
-          <a:lstStyle/>
-          <a:p>
-            <a:pPr algn="ctr"/>
-            <a:r>
-              <a:rPr sz="1400">
-                <a:solidFill>
-                  <a:srgbClr val="52606D"/>
-                </a:solidFill>
-                <a:latin typeface="Arial"/>
-              </a:rPr>
-              <a:t>Pending: Run 22 val_batch0_pred.jpg</a:t>
-            </a:r>
-          </a:p>
-        </p:txBody>
-      </p:sp>
+      </p:pic>
     </p:spTree>
   </p:cSld>
   <p:clrMapOvr>
@@ -10536,7 +10767,7 @@
                 </a:solidFill>
                 <a:latin typeface="Arial"/>
               </a:rPr>
-              <a:t>•  Early rot labeled as bruise</a:t>
+              <a:t>•  Unlabeled marks predicted as surface damage</a:t>
             </a:r>
           </a:p>
           <a:p>
@@ -10552,7 +10783,7 @@
                 </a:solidFill>
                 <a:latin typeface="Arial"/>
               </a:rPr>
-              <a:t>•  Glare and natural speckles flagged as damage</a:t>
+              <a:t>•  Partly visible defects at the fruit edge</a:t>
             </a:r>
           </a:p>
           <a:p>
@@ -10568,7 +10799,7 @@
                 </a:solidFill>
                 <a:latin typeface="Arial"/>
               </a:rPr>
-              <a:t>•  Busy backgrounds lower fruit mask quality</a:t>
+              <a:t>•  Masks smaller or larger than the labeled area</a:t>
             </a:r>
           </a:p>
         </p:txBody>
@@ -10912,7 +11143,7 @@
                 </a:solidFill>
                 <a:latin typeface="Arial"/>
               </a:rPr>
-              <a:t>Team masks: orange bruise or discoloration, red rot mold or decay, blue surface damage, green whole fruit</a:t>
+              <a:t>Team masks: orange bruise or discoloration, pink rot mold or decay, blue surface damage, green whole fruit</a:t>
             </a:r>
           </a:p>
         </p:txBody>
@@ -11832,7 +12063,7 @@
                 </a:solidFill>
                 <a:latin typeface="Arial"/>
               </a:rPr>
-              <a:t>•  Defects reach 0.688 validation and TBD test mask mAP50</a:t>
+              <a:t>•  Defects reach 0.688 validation and 0.613 test mask mAP50</a:t>
             </a:r>
           </a:p>
           <a:p>
@@ -11848,7 +12079,7 @@
                 </a:solidFill>
                 <a:latin typeface="Arial"/>
               </a:rPr>
-              <a:t>•  Rot is easiest and surface damage hardest</a:t>
+              <a:t>•  Rot is the most stable class and surface damage the hardest</a:t>
             </a:r>
           </a:p>
           <a:p>
@@ -16586,7 +16817,7 @@
                           </a:solidFill>
                           <a:latin typeface="Arial"/>
                         </a:rPr>
-                        <a:t>90</a:t>
+                        <a:t>124</a:t>
                       </a:r>
                     </a:p>
                   </a:txBody>

</xml_diff>

<commit_message>
Add near-duplicate leakage check, IoU, failure cases and app screenshot
Co-Authored-By: Claude Opus 5.5 <noreply@anthropic.com>
</commit_message>
<xml_diff>
--- a/slides/CIPHER_AI2_Final_Defense.pptx
+++ b/slides/CIPHER_AI2_Final_Defense.pptx
@@ -28,6 +28,7 @@
     <p:sldId id="276" r:id="rId28"/>
     <p:sldId id="277" r:id="rId29"/>
     <p:sldId id="278" r:id="rId30"/>
+    <p:sldId id="279" r:id="rId31"/>
   </p:sldIdLst>
   <p:sldSz cx="12191695" cy="6858000" type="screen4x3"/>
   <p:notesSz cx="6858000" cy="9144000"/>
@@ -1014,7 +1015,7 @@
           <a:lstStyle/>
           <a:p>
             <a:r>
-              <a:t>Tomato is the weakest fruit. Fill in the two-stage tomato numbers after training.</a:t>
+              <a:t>We found this ourselves after the test. Lab2Wild stores several photos of the same apple under different names, so our split by file ID did not catch them. We report both numbers and do not hide it.</a:t>
             </a:r>
           </a:p>
         </p:txBody>
@@ -1084,7 +1085,7 @@
           <a:lstStyle/>
           <a:p>
             <a:r>
-              <a:t>Left is the team label. Right is the model.</a:t>
+              <a:t>Tomato is the weakest fruit. Fill in the two-stage tomato numbers after training.</a:t>
             </a:r>
           </a:p>
         </p:txBody>
@@ -1154,7 +1155,7 @@
           <a:lstStyle/>
           <a:p>
             <a:r>
-              <a:t>Show real misses. Do not hide them.</a:t>
+              <a:t>Left is the team label. Right is the model.</a:t>
             </a:r>
           </a:p>
         </p:txBody>
@@ -1224,7 +1225,7 @@
           <a:lstStyle/>
           <a:p>
             <a:r>
-              <a:t>Switch to the live demo here. Samples work offline.</a:t>
+              <a:t>Show real misses. Do not hide them.</a:t>
             </a:r>
           </a:p>
         </p:txBody>
@@ -1320,6 +1321,76 @@
 </file>
 
 <file path=ppt/notesSlides/notesSlide20.xml><?xml version="1.0" encoding="utf-8"?>
+<p:notes xmlns:a="http://schemas.openxmlformats.org/drawingml/2006/main" xmlns:p="http://schemas.openxmlformats.org/presentationml/2006/main" xmlns:r="http://schemas.openxmlformats.org/officeDocument/2006/relationships">
+  <p:cSld>
+    <p:spTree>
+      <p:nvGrpSpPr>
+        <p:cNvPr id="1" name=""/>
+        <p:cNvGrpSpPr/>
+        <p:nvPr/>
+      </p:nvGrpSpPr>
+      <p:grpSpPr>
+        <a:xfrm>
+          <a:off x="0" y="0"/>
+          <a:ext cx="0" cy="0"/>
+          <a:chOff x="0" y="0"/>
+          <a:chExt cx="0" cy="0"/>
+        </a:xfrm>
+      </p:grpSpPr>
+      <p:sp>
+        <p:nvSpPr>
+          <p:cNvPr id="2" name="Slide Image Placeholder 1"/>
+          <p:cNvSpPr>
+            <a:spLocks noGrp="1"/>
+          </p:cNvSpPr>
+          <p:nvPr>
+            <p:ph type="sldImg" idx="2"/>
+          </p:nvPr>
+        </p:nvSpPr>
+        <p:spPr/>
+      </p:sp>
+      <p:sp>
+        <p:nvSpPr>
+          <p:cNvPr id="3" name="Notes Placeholder 2"/>
+          <p:cNvSpPr>
+            <a:spLocks noGrp="1"/>
+          </p:cNvSpPr>
+          <p:nvPr>
+            <p:ph type="body" idx="3" sz="quarter"/>
+          </p:nvPr>
+        </p:nvSpPr>
+        <p:spPr/>
+        <p:txBody>
+          <a:bodyPr/>
+          <a:lstStyle/>
+          <a:p>
+            <a:r>
+              <a:t>Switch to the live demo here. Samples work offline.</a:t>
+            </a:r>
+          </a:p>
+        </p:txBody>
+      </p:sp>
+      <p:sp>
+        <p:nvSpPr>
+          <p:cNvPr id="4" name="Slide Number Placeholder 3"/>
+          <p:cNvSpPr>
+            <a:spLocks noGrp="1"/>
+          </p:cNvSpPr>
+          <p:nvPr>
+            <p:ph type="sldNum" idx="5" sz="quarter"/>
+          </p:nvPr>
+        </p:nvSpPr>
+        <p:spPr/>
+      </p:sp>
+    </p:spTree>
+  </p:cSld>
+  <p:clrMapOvr>
+    <a:masterClrMapping/>
+  </p:clrMapOvr>
+</p:notes>
+</file>
+
+<file path=ppt/notesSlides/notesSlide21.xml><?xml version="1.0" encoding="utf-8"?>
 <p:notes xmlns:a="http://schemas.openxmlformats.org/drawingml/2006/main" xmlns:p="http://schemas.openxmlformats.org/presentationml/2006/main" xmlns:r="http://schemas.openxmlformats.org/officeDocument/2006/relationships">
   <p:cSld>
     <p:spTree>
@@ -9664,7 +9735,7 @@
                 </a:solidFill>
                 <a:latin typeface="Arial"/>
               </a:rPr>
-              <a:t>Tomato</a:t>
+              <a:t>Leakage check: near-duplicates</a:t>
             </a:r>
           </a:p>
         </p:txBody>
@@ -9790,17 +9861,41 @@
           </a:p>
         </p:txBody>
       </p:sp>
+      <p:pic>
+        <p:nvPicPr>
+          <p:cNvPr id="6" name="Picture 5" descr="near_duplicate_example.png"/>
+          <p:cNvPicPr>
+            <a:picLocks noChangeAspect="1"/>
+          </p:cNvPicPr>
+          <p:nvPr/>
+        </p:nvPicPr>
+        <p:blipFill>
+          <a:blip r:embed="rId3"/>
+          <a:stretch>
+            <a:fillRect/>
+          </a:stretch>
+        </p:blipFill>
+        <p:spPr>
+          <a:xfrm>
+            <a:off x="740664" y="1280160"/>
+            <a:ext cx="10680192" cy="2194560"/>
+          </a:xfrm>
+          <a:prstGeom prst="rect">
+            <a:avLst/>
+          </a:prstGeom>
+        </p:spPr>
+      </p:pic>
       <p:graphicFrame>
         <p:nvGraphicFramePr>
-          <p:cNvPr id="6" name="Table 5"/>
+          <p:cNvPr id="7" name="Table 6"/>
           <p:cNvGraphicFramePr>
             <a:graphicFrameLocks noGrp="1"/>
           </p:cNvGraphicFramePr>
           <p:nvPr/>
         </p:nvGraphicFramePr>
         <p:xfrm>
-          <a:off x="548640" y="1463040"/>
-          <a:ext cx="6400800" cy="1920240"/>
+          <a:off x="548640" y="3749039"/>
+          <a:ext cx="6035040" cy="1920240"/>
         </p:xfrm>
         <a:graphic>
           <a:graphicData uri="http://schemas.openxmlformats.org/drawingml/2006/table">
@@ -9809,9 +9904,9 @@
                 <a:tableStyleId>{5C22544A-7EE6-4342-B048-85BDC9FD1C3A}</a:tableStyleId>
               </a:tblPr>
               <a:tblGrid>
-                <a:gridCol w="2743200"/>
+                <a:gridCol w="2011680"/>
                 <a:gridCol w="1828800"/>
-                <a:gridCol w="1828800"/>
+                <a:gridCol w="2194560"/>
               </a:tblGrid>
               <a:tr h="384048">
                 <a:tc>
@@ -9827,7 +9922,7 @@
                           </a:solidFill>
                           <a:latin typeface="Arial"/>
                         </a:rPr>
-                        <a:t>Tomato two-stage</a:t>
+                        <a:t>Test mask mAP50</a:t>
                       </a:r>
                     </a:p>
                   </a:txBody>
@@ -9850,7 +9945,7 @@
                           </a:solidFill>
                           <a:latin typeface="Arial"/>
                         </a:rPr>
-                        <a:t>Validation</a:t>
+                        <a:t>All 79</a:t>
                       </a:r>
                     </a:p>
                   </a:txBody>
@@ -9873,7 +9968,7 @@
                           </a:solidFill>
                           <a:latin typeface="Arial"/>
                         </a:rPr>
-                        <a:t>Test</a:t>
+                        <a:t>59 without near-dups</a:t>
                       </a:r>
                     </a:p>
                   </a:txBody>
@@ -9898,7 +9993,7 @@
                           </a:solidFill>
                           <a:latin typeface="Arial"/>
                         </a:rPr>
-                        <a:t>Stage 1 fruit mAP50</a:t>
+                        <a:t>Bruise</a:t>
                       </a:r>
                     </a:p>
                   </a:txBody>
@@ -9921,7 +10016,7 @@
                           </a:solidFill>
                           <a:latin typeface="Arial"/>
                         </a:rPr>
-                        <a:t>TBD</a:t>
+                        <a:t>0.594</a:t>
                       </a:r>
                     </a:p>
                   </a:txBody>
@@ -9944,7 +10039,7 @@
                           </a:solidFill>
                           <a:latin typeface="Arial"/>
                         </a:rPr>
-                        <a:t>-</a:t>
+                        <a:t>0.305</a:t>
                       </a:r>
                     </a:p>
                   </a:txBody>
@@ -9969,7 +10064,7 @@
                           </a:solidFill>
                           <a:latin typeface="Arial"/>
                         </a:rPr>
-                        <a:t>Stage 2 defect precision</a:t>
+                        <a:t>Rot</a:t>
                       </a:r>
                     </a:p>
                   </a:txBody>
@@ -9992,7 +10087,7 @@
                           </a:solidFill>
                           <a:latin typeface="Arial"/>
                         </a:rPr>
-                        <a:t>TBD</a:t>
+                        <a:t>0.732</a:t>
                       </a:r>
                     </a:p>
                   </a:txBody>
@@ -10015,7 +10110,7 @@
                           </a:solidFill>
                           <a:latin typeface="Arial"/>
                         </a:rPr>
-                        <a:t>TBD</a:t>
+                        <a:t>0.693</a:t>
                       </a:r>
                     </a:p>
                   </a:txBody>
@@ -10040,7 +10135,7 @@
                           </a:solidFill>
                           <a:latin typeface="Arial"/>
                         </a:rPr>
-                        <a:t>Stage 2 defect recall</a:t>
+                        <a:t>Surface</a:t>
                       </a:r>
                     </a:p>
                   </a:txBody>
@@ -10063,7 +10158,7 @@
                           </a:solidFill>
                           <a:latin typeface="Arial"/>
                         </a:rPr>
-                        <a:t>TBD</a:t>
+                        <a:t>0.511</a:t>
                       </a:r>
                     </a:p>
                   </a:txBody>
@@ -10086,7 +10181,7 @@
                           </a:solidFill>
                           <a:latin typeface="Arial"/>
                         </a:rPr>
-                        <a:t>TBD</a:t>
+                        <a:t>0.515</a:t>
                       </a:r>
                     </a:p>
                   </a:txBody>
@@ -10111,7 +10206,7 @@
                           </a:solidFill>
                           <a:latin typeface="Arial"/>
                         </a:rPr>
-                        <a:t>Stage 2 defect mAP50</a:t>
+                        <a:t>All</a:t>
                       </a:r>
                     </a:p>
                   </a:txBody>
@@ -10134,7 +10229,7 @@
                           </a:solidFill>
                           <a:latin typeface="Arial"/>
                         </a:rPr>
-                        <a:t>TBD</a:t>
+                        <a:t>0.613</a:t>
                       </a:r>
                     </a:p>
                   </a:txBody>
@@ -10157,7 +10252,7 @@
                           </a:solidFill>
                           <a:latin typeface="Arial"/>
                         </a:rPr>
-                        <a:t>TBD</a:t>
+                        <a:t>0.504</a:t>
                       </a:r>
                     </a:p>
                   </a:txBody>
@@ -10174,14 +10269,14 @@
       </p:graphicFrame>
       <p:sp>
         <p:nvSpPr>
-          <p:cNvPr id="7" name="TextBox 6"/>
+          <p:cNvPr id="8" name="TextBox 7"/>
           <p:cNvSpPr txBox="1"/>
           <p:nvPr/>
         </p:nvSpPr>
         <p:spPr>
           <a:xfrm>
-            <a:off x="7315200" y="1554480"/>
-            <a:ext cx="4389120" cy="4389120"/>
+            <a:off x="6949440" y="3749039"/>
+            <a:ext cx="4754880" cy="2560320"/>
           </a:xfrm>
           <a:prstGeom prst="rect">
             <a:avLst/>
@@ -10200,13 +10295,13 @@
               </a:spcAft>
             </a:pPr>
             <a:r>
-              <a:rPr sz="1600" b="0">
+              <a:rPr sz="1500" b="0">
                 <a:solidFill>
                   <a:srgbClr val="1F2933"/>
                 </a:solidFill>
                 <a:latin typeface="Arial"/>
               </a:rPr>
-              <a:t>•  Earlier joint model (Run 11) on tomato validation:</a:t>
+              <a:t>•  Same apple in train and test, only rotated</a:t>
             </a:r>
           </a:p>
           <a:p>
@@ -10216,13 +10311,13 @@
               </a:spcAft>
             </a:pPr>
             <a:r>
-              <a:rPr sz="1600" b="0">
+              <a:rPr sz="1500" b="0">
                 <a:solidFill>
                   <a:srgbClr val="1F2933"/>
                 </a:solidFill>
                 <a:latin typeface="Arial"/>
               </a:rPr>
-              <a:t>•  Whole tomato 0.955 mAP50</a:t>
+              <a:t>•  20 of 79 test and 64 of 215 validation images matched</a:t>
             </a:r>
           </a:p>
           <a:p>
@@ -10232,13 +10327,13 @@
               </a:spcAft>
             </a:pPr>
             <a:r>
-              <a:rPr sz="1600" b="0">
+              <a:rPr sz="1500" b="0">
                 <a:solidFill>
                   <a:srgbClr val="1F2933"/>
                 </a:solidFill>
                 <a:latin typeface="Arial"/>
               </a:rPr>
-              <a:t>•  Bruise 0.419, rot 0.597, surface 0.347</a:t>
+              <a:t>•  Bruise score mostly came from seen apples</a:t>
             </a:r>
           </a:p>
           <a:p>
@@ -10248,13 +10343,13 @@
               </a:spcAft>
             </a:pPr>
             <a:r>
-              <a:rPr sz="1600" b="0">
+              <a:rPr sz="1500" b="0">
                 <a:solidFill>
                   <a:srgbClr val="1F2933"/>
                 </a:solidFill>
                 <a:latin typeface="Arial"/>
               </a:rPr>
-              <a:t>•  Fewer tomato defect examples than apple</a:t>
+              <a:t>•  0.504 is the fairer estimate for new photos</a:t>
             </a:r>
           </a:p>
         </p:txBody>
@@ -10311,7 +10406,7 @@
                 </a:solidFill>
                 <a:latin typeface="Arial"/>
               </a:rPr>
-              <a:t>Predictions vs ground truth</a:t>
+              <a:t>Tomato</a:t>
             </a:r>
           </a:p>
         </p:txBody>
@@ -10437,54 +10532,475 @@
           </a:p>
         </p:txBody>
       </p:sp>
-      <p:pic>
-        <p:nvPicPr>
-          <p:cNvPr id="6" name="Picture 5" descr="val_batch0_labels.jpg"/>
-          <p:cNvPicPr>
-            <a:picLocks noChangeAspect="1"/>
-          </p:cNvPicPr>
+      <p:graphicFrame>
+        <p:nvGraphicFramePr>
+          <p:cNvPr id="6" name="Table 5"/>
+          <p:cNvGraphicFramePr>
+            <a:graphicFrameLocks noGrp="1"/>
+          </p:cNvGraphicFramePr>
           <p:nvPr/>
-        </p:nvPicPr>
-        <p:blipFill>
-          <a:blip r:embed="rId3"/>
-          <a:stretch>
-            <a:fillRect/>
-          </a:stretch>
-        </p:blipFill>
+        </p:nvGraphicFramePr>
+        <p:xfrm>
+          <a:off x="548640" y="1463040"/>
+          <a:ext cx="6400800" cy="1920240"/>
+        </p:xfrm>
+        <a:graphic>
+          <a:graphicData uri="http://schemas.openxmlformats.org/drawingml/2006/table">
+            <a:tbl>
+              <a:tblPr firstRow="1" bandRow="1">
+                <a:tableStyleId>{5C22544A-7EE6-4342-B048-85BDC9FD1C3A}</a:tableStyleId>
+              </a:tblPr>
+              <a:tblGrid>
+                <a:gridCol w="2743200"/>
+                <a:gridCol w="1828800"/>
+                <a:gridCol w="1828800"/>
+              </a:tblGrid>
+              <a:tr h="384048">
+                <a:tc>
+                  <a:txBody>
+                    <a:bodyPr/>
+                    <a:lstStyle/>
+                    <a:p>
+                      <a:pPr algn="l"/>
+                      <a:r>
+                        <a:rPr sz="1300" b="1">
+                          <a:solidFill>
+                            <a:srgbClr val="FFFFFF"/>
+                          </a:solidFill>
+                          <a:latin typeface="Arial"/>
+                        </a:rPr>
+                        <a:t>Tomato two-stage</a:t>
+                      </a:r>
+                    </a:p>
+                  </a:txBody>
+                  <a:tcPr>
+                    <a:solidFill>
+                      <a:srgbClr val="1F2933"/>
+                    </a:solidFill>
+                  </a:tcPr>
+                </a:tc>
+                <a:tc>
+                  <a:txBody>
+                    <a:bodyPr/>
+                    <a:lstStyle/>
+                    <a:p>
+                      <a:pPr algn="ctr"/>
+                      <a:r>
+                        <a:rPr sz="1300" b="1">
+                          <a:solidFill>
+                            <a:srgbClr val="FFFFFF"/>
+                          </a:solidFill>
+                          <a:latin typeface="Arial"/>
+                        </a:rPr>
+                        <a:t>Validation</a:t>
+                      </a:r>
+                    </a:p>
+                  </a:txBody>
+                  <a:tcPr>
+                    <a:solidFill>
+                      <a:srgbClr val="1F2933"/>
+                    </a:solidFill>
+                  </a:tcPr>
+                </a:tc>
+                <a:tc>
+                  <a:txBody>
+                    <a:bodyPr/>
+                    <a:lstStyle/>
+                    <a:p>
+                      <a:pPr algn="ctr"/>
+                      <a:r>
+                        <a:rPr sz="1300" b="1">
+                          <a:solidFill>
+                            <a:srgbClr val="FFFFFF"/>
+                          </a:solidFill>
+                          <a:latin typeface="Arial"/>
+                        </a:rPr>
+                        <a:t>Test</a:t>
+                      </a:r>
+                    </a:p>
+                  </a:txBody>
+                  <a:tcPr>
+                    <a:solidFill>
+                      <a:srgbClr val="1F2933"/>
+                    </a:solidFill>
+                  </a:tcPr>
+                </a:tc>
+              </a:tr>
+              <a:tr h="384048">
+                <a:tc>
+                  <a:txBody>
+                    <a:bodyPr/>
+                    <a:lstStyle/>
+                    <a:p>
+                      <a:pPr algn="l"/>
+                      <a:r>
+                        <a:rPr sz="1300" b="0">
+                          <a:solidFill>
+                            <a:srgbClr val="1F2933"/>
+                          </a:solidFill>
+                          <a:latin typeface="Arial"/>
+                        </a:rPr>
+                        <a:t>Stage 1 fruit mAP50</a:t>
+                      </a:r>
+                    </a:p>
+                  </a:txBody>
+                  <a:tcPr>
+                    <a:solidFill>
+                      <a:srgbClr val="FFFFFF"/>
+                    </a:solidFill>
+                  </a:tcPr>
+                </a:tc>
+                <a:tc>
+                  <a:txBody>
+                    <a:bodyPr/>
+                    <a:lstStyle/>
+                    <a:p>
+                      <a:pPr algn="ctr"/>
+                      <a:r>
+                        <a:rPr sz="1300" b="0">
+                          <a:solidFill>
+                            <a:srgbClr val="1F2933"/>
+                          </a:solidFill>
+                          <a:latin typeface="Arial"/>
+                        </a:rPr>
+                        <a:t>TBD</a:t>
+                      </a:r>
+                    </a:p>
+                  </a:txBody>
+                  <a:tcPr>
+                    <a:solidFill>
+                      <a:srgbClr val="FFFFFF"/>
+                    </a:solidFill>
+                  </a:tcPr>
+                </a:tc>
+                <a:tc>
+                  <a:txBody>
+                    <a:bodyPr/>
+                    <a:lstStyle/>
+                    <a:p>
+                      <a:pPr algn="ctr"/>
+                      <a:r>
+                        <a:rPr sz="1300" b="0">
+                          <a:solidFill>
+                            <a:srgbClr val="1F2933"/>
+                          </a:solidFill>
+                          <a:latin typeface="Arial"/>
+                        </a:rPr>
+                        <a:t>-</a:t>
+                      </a:r>
+                    </a:p>
+                  </a:txBody>
+                  <a:tcPr>
+                    <a:solidFill>
+                      <a:srgbClr val="FFFFFF"/>
+                    </a:solidFill>
+                  </a:tcPr>
+                </a:tc>
+              </a:tr>
+              <a:tr h="384048">
+                <a:tc>
+                  <a:txBody>
+                    <a:bodyPr/>
+                    <a:lstStyle/>
+                    <a:p>
+                      <a:pPr algn="l"/>
+                      <a:r>
+                        <a:rPr sz="1300" b="0">
+                          <a:solidFill>
+                            <a:srgbClr val="1F2933"/>
+                          </a:solidFill>
+                          <a:latin typeface="Arial"/>
+                        </a:rPr>
+                        <a:t>Stage 2 defect precision</a:t>
+                      </a:r>
+                    </a:p>
+                  </a:txBody>
+                  <a:tcPr>
+                    <a:solidFill>
+                      <a:srgbClr val="F5F7FA"/>
+                    </a:solidFill>
+                  </a:tcPr>
+                </a:tc>
+                <a:tc>
+                  <a:txBody>
+                    <a:bodyPr/>
+                    <a:lstStyle/>
+                    <a:p>
+                      <a:pPr algn="ctr"/>
+                      <a:r>
+                        <a:rPr sz="1300" b="0">
+                          <a:solidFill>
+                            <a:srgbClr val="1F2933"/>
+                          </a:solidFill>
+                          <a:latin typeface="Arial"/>
+                        </a:rPr>
+                        <a:t>TBD</a:t>
+                      </a:r>
+                    </a:p>
+                  </a:txBody>
+                  <a:tcPr>
+                    <a:solidFill>
+                      <a:srgbClr val="F5F7FA"/>
+                    </a:solidFill>
+                  </a:tcPr>
+                </a:tc>
+                <a:tc>
+                  <a:txBody>
+                    <a:bodyPr/>
+                    <a:lstStyle/>
+                    <a:p>
+                      <a:pPr algn="ctr"/>
+                      <a:r>
+                        <a:rPr sz="1300" b="0">
+                          <a:solidFill>
+                            <a:srgbClr val="1F2933"/>
+                          </a:solidFill>
+                          <a:latin typeface="Arial"/>
+                        </a:rPr>
+                        <a:t>TBD</a:t>
+                      </a:r>
+                    </a:p>
+                  </a:txBody>
+                  <a:tcPr>
+                    <a:solidFill>
+                      <a:srgbClr val="F5F7FA"/>
+                    </a:solidFill>
+                  </a:tcPr>
+                </a:tc>
+              </a:tr>
+              <a:tr h="384048">
+                <a:tc>
+                  <a:txBody>
+                    <a:bodyPr/>
+                    <a:lstStyle/>
+                    <a:p>
+                      <a:pPr algn="l"/>
+                      <a:r>
+                        <a:rPr sz="1300" b="0">
+                          <a:solidFill>
+                            <a:srgbClr val="1F2933"/>
+                          </a:solidFill>
+                          <a:latin typeface="Arial"/>
+                        </a:rPr>
+                        <a:t>Stage 2 defect recall</a:t>
+                      </a:r>
+                    </a:p>
+                  </a:txBody>
+                  <a:tcPr>
+                    <a:solidFill>
+                      <a:srgbClr val="FFFFFF"/>
+                    </a:solidFill>
+                  </a:tcPr>
+                </a:tc>
+                <a:tc>
+                  <a:txBody>
+                    <a:bodyPr/>
+                    <a:lstStyle/>
+                    <a:p>
+                      <a:pPr algn="ctr"/>
+                      <a:r>
+                        <a:rPr sz="1300" b="0">
+                          <a:solidFill>
+                            <a:srgbClr val="1F2933"/>
+                          </a:solidFill>
+                          <a:latin typeface="Arial"/>
+                        </a:rPr>
+                        <a:t>TBD</a:t>
+                      </a:r>
+                    </a:p>
+                  </a:txBody>
+                  <a:tcPr>
+                    <a:solidFill>
+                      <a:srgbClr val="FFFFFF"/>
+                    </a:solidFill>
+                  </a:tcPr>
+                </a:tc>
+                <a:tc>
+                  <a:txBody>
+                    <a:bodyPr/>
+                    <a:lstStyle/>
+                    <a:p>
+                      <a:pPr algn="ctr"/>
+                      <a:r>
+                        <a:rPr sz="1300" b="0">
+                          <a:solidFill>
+                            <a:srgbClr val="1F2933"/>
+                          </a:solidFill>
+                          <a:latin typeface="Arial"/>
+                        </a:rPr>
+                        <a:t>TBD</a:t>
+                      </a:r>
+                    </a:p>
+                  </a:txBody>
+                  <a:tcPr>
+                    <a:solidFill>
+                      <a:srgbClr val="FFFFFF"/>
+                    </a:solidFill>
+                  </a:tcPr>
+                </a:tc>
+              </a:tr>
+              <a:tr h="384048">
+                <a:tc>
+                  <a:txBody>
+                    <a:bodyPr/>
+                    <a:lstStyle/>
+                    <a:p>
+                      <a:pPr algn="l"/>
+                      <a:r>
+                        <a:rPr sz="1300" b="0">
+                          <a:solidFill>
+                            <a:srgbClr val="1F2933"/>
+                          </a:solidFill>
+                          <a:latin typeface="Arial"/>
+                        </a:rPr>
+                        <a:t>Stage 2 defect mAP50</a:t>
+                      </a:r>
+                    </a:p>
+                  </a:txBody>
+                  <a:tcPr>
+                    <a:solidFill>
+                      <a:srgbClr val="F5F7FA"/>
+                    </a:solidFill>
+                  </a:tcPr>
+                </a:tc>
+                <a:tc>
+                  <a:txBody>
+                    <a:bodyPr/>
+                    <a:lstStyle/>
+                    <a:p>
+                      <a:pPr algn="ctr"/>
+                      <a:r>
+                        <a:rPr sz="1300" b="0">
+                          <a:solidFill>
+                            <a:srgbClr val="1F2933"/>
+                          </a:solidFill>
+                          <a:latin typeface="Arial"/>
+                        </a:rPr>
+                        <a:t>TBD</a:t>
+                      </a:r>
+                    </a:p>
+                  </a:txBody>
+                  <a:tcPr>
+                    <a:solidFill>
+                      <a:srgbClr val="F5F7FA"/>
+                    </a:solidFill>
+                  </a:tcPr>
+                </a:tc>
+                <a:tc>
+                  <a:txBody>
+                    <a:bodyPr/>
+                    <a:lstStyle/>
+                    <a:p>
+                      <a:pPr algn="ctr"/>
+                      <a:r>
+                        <a:rPr sz="1300" b="0">
+                          <a:solidFill>
+                            <a:srgbClr val="1F2933"/>
+                          </a:solidFill>
+                          <a:latin typeface="Arial"/>
+                        </a:rPr>
+                        <a:t>TBD</a:t>
+                      </a:r>
+                    </a:p>
+                  </a:txBody>
+                  <a:tcPr>
+                    <a:solidFill>
+                      <a:srgbClr val="F5F7FA"/>
+                    </a:solidFill>
+                  </a:tcPr>
+                </a:tc>
+              </a:tr>
+            </a:tbl>
+          </a:graphicData>
+        </a:graphic>
+      </p:graphicFrame>
+      <p:sp>
+        <p:nvSpPr>
+          <p:cNvPr id="7" name="TextBox 6"/>
+          <p:cNvSpPr txBox="1"/>
+          <p:nvPr/>
+        </p:nvSpPr>
         <p:spPr>
           <a:xfrm>
-            <a:off x="548640" y="1645920"/>
-            <a:ext cx="5486400" cy="4114800"/>
+            <a:off x="7315200" y="1554480"/>
+            <a:ext cx="4389120" cy="4389120"/>
           </a:xfrm>
           <a:prstGeom prst="rect">
             <a:avLst/>
           </a:prstGeom>
+          <a:noFill/>
         </p:spPr>
-      </p:pic>
-      <p:pic>
-        <p:nvPicPr>
-          <p:cNvPr id="7" name="Picture 6" descr="val_batch0_pred.jpg"/>
-          <p:cNvPicPr>
-            <a:picLocks noChangeAspect="1"/>
-          </p:cNvPicPr>
-          <p:nvPr/>
-        </p:nvPicPr>
-        <p:blipFill>
-          <a:blip r:embed="rId4"/>
-          <a:stretch>
-            <a:fillRect/>
-          </a:stretch>
-        </p:blipFill>
-        <p:spPr>
-          <a:xfrm>
-            <a:off x="6217920" y="1645920"/>
-            <a:ext cx="5486400" cy="4114800"/>
-          </a:xfrm>
-          <a:prstGeom prst="rect">
-            <a:avLst/>
-          </a:prstGeom>
-        </p:spPr>
-      </p:pic>
+        <p:txBody>
+          <a:bodyPr wrap="square" anchor="t">
+            <a:spAutoFit/>
+          </a:bodyPr>
+          <a:lstStyle/>
+          <a:p>
+            <a:pPr algn="l">
+              <a:spcAft>
+                <a:spcPts val="800"/>
+              </a:spcAft>
+            </a:pPr>
+            <a:r>
+              <a:rPr sz="1600" b="0">
+                <a:solidFill>
+                  <a:srgbClr val="1F2933"/>
+                </a:solidFill>
+                <a:latin typeface="Arial"/>
+              </a:rPr>
+              <a:t>•  Earlier joint model (Run 11) on tomato validation:</a:t>
+            </a:r>
+          </a:p>
+          <a:p>
+            <a:pPr algn="l">
+              <a:spcAft>
+                <a:spcPts val="800"/>
+              </a:spcAft>
+            </a:pPr>
+            <a:r>
+              <a:rPr sz="1600" b="0">
+                <a:solidFill>
+                  <a:srgbClr val="1F2933"/>
+                </a:solidFill>
+                <a:latin typeface="Arial"/>
+              </a:rPr>
+              <a:t>•  Whole tomato 0.955 mAP50</a:t>
+            </a:r>
+          </a:p>
+          <a:p>
+            <a:pPr algn="l">
+              <a:spcAft>
+                <a:spcPts val="800"/>
+              </a:spcAft>
+            </a:pPr>
+            <a:r>
+              <a:rPr sz="1600" b="0">
+                <a:solidFill>
+                  <a:srgbClr val="1F2933"/>
+                </a:solidFill>
+                <a:latin typeface="Arial"/>
+              </a:rPr>
+              <a:t>•  Bruise 0.419, rot 0.597, surface 0.347</a:t>
+            </a:r>
+          </a:p>
+          <a:p>
+            <a:pPr algn="l">
+              <a:spcAft>
+                <a:spcPts val="800"/>
+              </a:spcAft>
+            </a:pPr>
+            <a:r>
+              <a:rPr sz="1600" b="0">
+                <a:solidFill>
+                  <a:srgbClr val="1F2933"/>
+                </a:solidFill>
+                <a:latin typeface="Arial"/>
+              </a:rPr>
+              <a:t>•  Fewer tomato defect examples than apple</a:t>
+            </a:r>
+          </a:p>
+        </p:txBody>
+      </p:sp>
     </p:spTree>
   </p:cSld>
   <p:clrMapOvr>
@@ -10537,7 +11053,7 @@
                 </a:solidFill>
                 <a:latin typeface="Arial"/>
               </a:rPr>
-              <a:t>Failure cases</a:t>
+              <a:t>Good predictions on clean test images</a:t>
             </a:r>
           </a:p>
         </p:txBody>
@@ -10663,60 +11179,30 @@
           </a:p>
         </p:txBody>
       </p:sp>
-      <p:sp>
-        <p:nvSpPr>
-          <p:cNvPr id="6" name="Rectangle 5"/>
-          <p:cNvSpPr/>
+      <p:pic>
+        <p:nvPicPr>
+          <p:cNvPr id="6" name="Picture 5" descr="good_predictions.png"/>
+          <p:cNvPicPr>
+            <a:picLocks noChangeAspect="1"/>
+          </p:cNvPicPr>
           <p:nvPr/>
-        </p:nvSpPr>
+        </p:nvPicPr>
+        <p:blipFill>
+          <a:blip r:embed="rId3"/>
+          <a:stretch>
+            <a:fillRect/>
+          </a:stretch>
+        </p:blipFill>
         <p:spPr>
           <a:xfrm>
-            <a:off x="548640" y="1280160"/>
-            <a:ext cx="6949440" cy="4846320"/>
+            <a:off x="556659" y="1280160"/>
+            <a:ext cx="11048202" cy="4663440"/>
           </a:xfrm>
           <a:prstGeom prst="rect">
             <a:avLst/>
           </a:prstGeom>
-          <a:solidFill>
-            <a:srgbClr val="F5F7FA"/>
-          </a:solidFill>
-          <a:ln>
-            <a:solidFill>
-              <a:srgbClr val="CBD2D9"/>
-            </a:solidFill>
-          </a:ln>
         </p:spPr>
-        <p:style>
-          <a:lnRef idx="1">
-            <a:schemeClr val="accent1"/>
-          </a:lnRef>
-          <a:fillRef idx="3">
-            <a:schemeClr val="accent1"/>
-          </a:fillRef>
-          <a:effectRef idx="2">
-            <a:schemeClr val="accent1"/>
-          </a:effectRef>
-          <a:fontRef idx="minor">
-            <a:schemeClr val="lt1"/>
-          </a:fontRef>
-        </p:style>
-        <p:txBody>
-          <a:bodyPr rtlCol="0" anchor="ctr"/>
-          <a:lstStyle/>
-          <a:p>
-            <a:pPr algn="ctr"/>
-            <a:r>
-              <a:rPr sz="1400">
-                <a:solidFill>
-                  <a:srgbClr val="52606D"/>
-                </a:solidFill>
-                <a:latin typeface="Arial"/>
-              </a:rPr>
-              <a:t>Pending: failure_cases.png</a:t>
-            </a:r>
-          </a:p>
-        </p:txBody>
-      </p:sp>
+      </p:pic>
       <p:sp>
         <p:nvSpPr>
           <p:cNvPr id="7" name="TextBox 6"/>
@@ -10725,8 +11211,8 @@
         </p:nvSpPr>
         <p:spPr>
           <a:xfrm>
-            <a:off x="7772400" y="1554480"/>
-            <a:ext cx="3931920" cy="4389120"/>
+            <a:off x="548640" y="5943600"/>
+            <a:ext cx="10972800" cy="365760"/>
           </a:xfrm>
           <a:prstGeom prst="rect">
             <a:avLst/>
@@ -10745,61 +11231,13 @@
               </a:spcAft>
             </a:pPr>
             <a:r>
-              <a:rPr sz="1600" b="0">
-                <a:solidFill>
-                  <a:srgbClr val="1F2933"/>
+              <a:rPr sz="1300" b="0">
+                <a:solidFill>
+                  <a:srgbClr val="52606D"/>
                 </a:solidFill>
                 <a:latin typeface="Arial"/>
               </a:rPr>
-              <a:t>•  Small faint scars are missed</a:t>
-            </a:r>
-          </a:p>
-          <a:p>
-            <a:pPr algn="l">
-              <a:spcAft>
-                <a:spcPts val="800"/>
-              </a:spcAft>
-            </a:pPr>
-            <a:r>
-              <a:rPr sz="1600" b="0">
-                <a:solidFill>
-                  <a:srgbClr val="1F2933"/>
-                </a:solidFill>
-                <a:latin typeface="Arial"/>
-              </a:rPr>
-              <a:t>•  Unlabeled marks predicted as surface damage</a:t>
-            </a:r>
-          </a:p>
-          <a:p>
-            <a:pPr algn="l">
-              <a:spcAft>
-                <a:spcPts val="800"/>
-              </a:spcAft>
-            </a:pPr>
-            <a:r>
-              <a:rPr sz="1600" b="0">
-                <a:solidFill>
-                  <a:srgbClr val="1F2933"/>
-                </a:solidFill>
-                <a:latin typeface="Arial"/>
-              </a:rPr>
-              <a:t>•  Partly visible defects at the fruit edge</a:t>
-            </a:r>
-          </a:p>
-          <a:p>
-            <a:pPr algn="l">
-              <a:spcAft>
-                <a:spcPts val="800"/>
-              </a:spcAft>
-            </a:pPr>
-            <a:r>
-              <a:rPr sz="1600" b="0">
-                <a:solidFill>
-                  <a:srgbClr val="1F2933"/>
-                </a:solidFill>
-                <a:latin typeface="Arial"/>
-              </a:rPr>
-              <a:t>•  Masks smaller or larger than the labeled area</a:t>
+              <a:t>Test images. Mean per-image pixel IoU over 62 test images with a defect: 0.583</a:t>
             </a:r>
           </a:p>
         </p:txBody>
@@ -11200,7 +11638,7 @@
                 </a:solidFill>
                 <a:latin typeface="Arial"/>
               </a:rPr>
-              <a:t>Web application (Streamlit)</a:t>
+              <a:t>Failure cases</a:t>
             </a:r>
           </a:p>
         </p:txBody>
@@ -11326,60 +11764,30 @@
           </a:p>
         </p:txBody>
       </p:sp>
-      <p:sp>
-        <p:nvSpPr>
-          <p:cNvPr id="6" name="Rectangle 5"/>
-          <p:cNvSpPr/>
+      <p:pic>
+        <p:nvPicPr>
+          <p:cNvPr id="6" name="Picture 5" descr="failure_cases.png"/>
+          <p:cNvPicPr>
+            <a:picLocks noChangeAspect="1"/>
+          </p:cNvPicPr>
           <p:nvPr/>
-        </p:nvSpPr>
+        </p:nvPicPr>
+        <p:blipFill>
+          <a:blip r:embed="rId3"/>
+          <a:stretch>
+            <a:fillRect/>
+          </a:stretch>
+        </p:blipFill>
         <p:spPr>
           <a:xfrm>
-            <a:off x="548640" y="1280160"/>
-            <a:ext cx="7315200" cy="4846320"/>
+            <a:off x="365760" y="2043659"/>
+            <a:ext cx="7863840" cy="3319322"/>
           </a:xfrm>
           <a:prstGeom prst="rect">
             <a:avLst/>
           </a:prstGeom>
-          <a:solidFill>
-            <a:srgbClr val="F5F7FA"/>
-          </a:solidFill>
-          <a:ln>
-            <a:solidFill>
-              <a:srgbClr val="CBD2D9"/>
-            </a:solidFill>
-          </a:ln>
         </p:spPr>
-        <p:style>
-          <a:lnRef idx="1">
-            <a:schemeClr val="accent1"/>
-          </a:lnRef>
-          <a:fillRef idx="3">
-            <a:schemeClr val="accent1"/>
-          </a:fillRef>
-          <a:effectRef idx="2">
-            <a:schemeClr val="accent1"/>
-          </a:effectRef>
-          <a:fontRef idx="minor">
-            <a:schemeClr val="lt1"/>
-          </a:fontRef>
-        </p:style>
-        <p:txBody>
-          <a:bodyPr rtlCol="0" anchor="ctr"/>
-          <a:lstStyle/>
-          <a:p>
-            <a:pPr algn="ctr"/>
-            <a:r>
-              <a:rPr sz="1400">
-                <a:solidFill>
-                  <a:srgbClr val="52606D"/>
-                </a:solidFill>
-                <a:latin typeface="Arial"/>
-              </a:rPr>
-              <a:t>Pending: app_screenshot.png</a:t>
-            </a:r>
-          </a:p>
-        </p:txBody>
-      </p:sp>
+      </p:pic>
       <p:sp>
         <p:nvSpPr>
           <p:cNvPr id="7" name="TextBox 6"/>
@@ -11388,8 +11796,8 @@
         </p:nvSpPr>
         <p:spPr>
           <a:xfrm>
-            <a:off x="8138160" y="1463040"/>
-            <a:ext cx="3566160" cy="4572000"/>
+            <a:off x="8412480" y="1554480"/>
+            <a:ext cx="3383280" cy="4389120"/>
           </a:xfrm>
           <a:prstGeom prst="rect">
             <a:avLst/>
@@ -11408,13 +11816,13 @@
               </a:spcAft>
             </a:pPr>
             <a:r>
-              <a:rPr sz="1500" b="0">
+              <a:rPr sz="1600" b="0">
                 <a:solidFill>
                   <a:srgbClr val="1F2933"/>
                 </a:solidFill>
                 <a:latin typeface="Arial"/>
               </a:rPr>
-              <a:t>•  Pick apple or tomato</a:t>
+              <a:t>•  Rot predicted as bruise on a discolored apple</a:t>
             </a:r>
           </a:p>
           <a:p>
@@ -11424,13 +11832,13 @@
               </a:spcAft>
             </a:pPr>
             <a:r>
-              <a:rPr sz="1500" b="0">
+              <a:rPr sz="1600" b="0">
                 <a:solidFill>
                   <a:srgbClr val="1F2933"/>
                 </a:solidFill>
                 <a:latin typeface="Arial"/>
               </a:rPr>
-              <a:t>•  Upload a photo or use a sample</a:t>
+              <a:t>•  Whole-fruit rot label not found by the model</a:t>
             </a:r>
           </a:p>
           <a:p>
@@ -11440,13 +11848,13 @@
               </a:spcAft>
             </a:pPr>
             <a:r>
-              <a:rPr sz="1500" b="0">
+              <a:rPr sz="1600" b="0">
                 <a:solidFill>
                   <a:srgbClr val="1F2933"/>
                 </a:solidFill>
                 <a:latin typeface="Arial"/>
               </a:rPr>
-              <a:t>•  Colored masks with a legend</a:t>
+              <a:t>•  Tiny surface damage missed</a:t>
             </a:r>
           </a:p>
           <a:p>
@@ -11456,61 +11864,13 @@
               </a:spcAft>
             </a:pPr>
             <a:r>
-              <a:rPr sz="1500" b="0">
+              <a:rPr sz="1600" b="0">
                 <a:solidFill>
                   <a:srgbClr val="1F2933"/>
                 </a:solidFill>
                 <a:latin typeface="Arial"/>
               </a:rPr>
-              <a:t>•  Defect share of the image and of the fruit</a:t>
-            </a:r>
-          </a:p>
-          <a:p>
-            <a:pPr algn="l">
-              <a:spcAft>
-                <a:spcPts val="800"/>
-              </a:spcAft>
-            </a:pPr>
-            <a:r>
-              <a:rPr sz="1500" b="0">
-                <a:solidFill>
-                  <a:srgbClr val="1F2933"/>
-                </a:solidFill>
-                <a:latin typeface="Arial"/>
-              </a:rPr>
-              <a:t>•  Confidence slider and class toggles</a:t>
-            </a:r>
-          </a:p>
-          <a:p>
-            <a:pPr algn="l">
-              <a:spcAft>
-                <a:spcPts val="800"/>
-              </a:spcAft>
-            </a:pPr>
-            <a:r>
-              <a:rPr sz="1500" b="0">
-                <a:solidFill>
-                  <a:srgbClr val="1F2933"/>
-                </a:solidFill>
-                <a:latin typeface="Arial"/>
-              </a:rPr>
-              <a:t>•  Download the result as PNG</a:t>
-            </a:r>
-          </a:p>
-          <a:p>
-            <a:pPr algn="l">
-              <a:spcAft>
-                <a:spcPts val="800"/>
-              </a:spcAft>
-            </a:pPr>
-            <a:r>
-              <a:rPr sz="1500" b="0">
-                <a:solidFill>
-                  <a:srgbClr val="1F2933"/>
-                </a:solidFill>
-                <a:latin typeface="Arial"/>
-              </a:rPr>
-              <a:t>•  Clear messages for bad files or no defects</a:t>
+              <a:t>•  Edge mark predicted as surface damage on clean skin</a:t>
             </a:r>
           </a:p>
         </p:txBody>
@@ -11567,7 +11927,7 @@
                 </a:solidFill>
                 <a:latin typeface="Arial"/>
               </a:rPr>
-              <a:t>Limitations</a:t>
+              <a:t>Web application (Streamlit)</a:t>
             </a:r>
           </a:p>
         </p:txBody>
@@ -11693,16 +12053,40 @@
           </a:p>
         </p:txBody>
       </p:sp>
-      <p:sp>
-        <p:nvSpPr>
-          <p:cNvPr id="6" name="TextBox 5"/>
+      <p:pic>
+        <p:nvPicPr>
+          <p:cNvPr id="6" name="Picture 5" descr="app_screenshot.png"/>
+          <p:cNvPicPr>
+            <a:picLocks noChangeAspect="1"/>
+          </p:cNvPicPr>
+          <p:nvPr/>
+        </p:nvPicPr>
+        <p:blipFill>
+          <a:blip r:embed="rId3"/>
+          <a:stretch>
+            <a:fillRect/>
+          </a:stretch>
+        </p:blipFill>
+        <p:spPr>
+          <a:xfrm>
+            <a:off x="1045597" y="1280160"/>
+            <a:ext cx="6321286" cy="4846320"/>
+          </a:xfrm>
+          <a:prstGeom prst="rect">
+            <a:avLst/>
+          </a:prstGeom>
+        </p:spPr>
+      </p:pic>
+      <p:sp>
+        <p:nvSpPr>
+          <p:cNvPr id="7" name="TextBox 6"/>
           <p:cNvSpPr txBox="1"/>
           <p:nvPr/>
         </p:nvSpPr>
         <p:spPr>
           <a:xfrm>
-            <a:off x="548640" y="1463040"/>
-            <a:ext cx="10972800" cy="4572000"/>
+            <a:off x="8138160" y="1463040"/>
+            <a:ext cx="3566160" cy="4572000"/>
           </a:xfrm>
           <a:prstGeom prst="rect">
             <a:avLst/>
@@ -11721,13 +12105,13 @@
               </a:spcAft>
             </a:pPr>
             <a:r>
-              <a:rPr sz="1800" b="0">
+              <a:rPr sz="1500" b="0">
                 <a:solidFill>
                   <a:srgbClr val="1F2933"/>
                 </a:solidFill>
                 <a:latin typeface="Arial"/>
               </a:rPr>
-              <a:t>•  Labels describe appearance only. The model does not diagnose disease or internal damage</a:t>
+              <a:t>•  Pick apple or tomato</a:t>
             </a:r>
           </a:p>
           <a:p>
@@ -11737,13 +12121,13 @@
               </a:spcAft>
             </a:pPr>
             <a:r>
-              <a:rPr sz="1800" b="0">
+              <a:rPr sz="1500" b="0">
                 <a:solidFill>
                   <a:srgbClr val="1F2933"/>
                 </a:solidFill>
                 <a:latin typeface="Arial"/>
               </a:rPr>
-              <a:t>•  Few image sources with mostly plain backgrounds</a:t>
+              <a:t>•  Upload a photo or use a sample</a:t>
             </a:r>
           </a:p>
           <a:p>
@@ -11753,13 +12137,13 @@
               </a:spcAft>
             </a:pPr>
             <a:r>
-              <a:rPr sz="1800" b="0">
+              <a:rPr sz="1500" b="0">
                 <a:solidFill>
                   <a:srgbClr val="1F2933"/>
                 </a:solidFill>
                 <a:latin typeface="Arial"/>
               </a:rPr>
-              <a:t>•  Small surface damage remains hard and lowers recall</a:t>
+              <a:t>•  Colored masks with a legend</a:t>
             </a:r>
           </a:p>
           <a:p>
@@ -11769,13 +12153,13 @@
               </a:spcAft>
             </a:pPr>
             <a:r>
-              <a:rPr sz="1800" b="0">
+              <a:rPr sz="1500" b="0">
                 <a:solidFill>
                   <a:srgbClr val="1F2933"/>
                 </a:solidFill>
                 <a:latin typeface="Arial"/>
               </a:rPr>
-              <a:t>•  Two-stage gain is not isolated from model size and settings</a:t>
+              <a:t>•  Defect share of the image and of the fruit</a:t>
             </a:r>
           </a:p>
           <a:p>
@@ -11785,13 +12169,45 @@
               </a:spcAft>
             </a:pPr>
             <a:r>
-              <a:rPr sz="1800" b="0">
+              <a:rPr sz="1500" b="0">
                 <a:solidFill>
                   <a:srgbClr val="1F2933"/>
                 </a:solidFill>
                 <a:latin typeface="Arial"/>
               </a:rPr>
-              <a:t>•  One annotator per image with review. No formal agreement score yet</a:t>
+              <a:t>•  Confidence slider and class toggles</a:t>
+            </a:r>
+          </a:p>
+          <a:p>
+            <a:pPr algn="l">
+              <a:spcAft>
+                <a:spcPts val="800"/>
+              </a:spcAft>
+            </a:pPr>
+            <a:r>
+              <a:rPr sz="1500" b="0">
+                <a:solidFill>
+                  <a:srgbClr val="1F2933"/>
+                </a:solidFill>
+                <a:latin typeface="Arial"/>
+              </a:rPr>
+              <a:t>•  Download the result as PNG</a:t>
+            </a:r>
+          </a:p>
+          <a:p>
+            <a:pPr algn="l">
+              <a:spcAft>
+                <a:spcPts val="800"/>
+              </a:spcAft>
+            </a:pPr>
+            <a:r>
+              <a:rPr sz="1500" b="0">
+                <a:solidFill>
+                  <a:srgbClr val="1F2933"/>
+                </a:solidFill>
+                <a:latin typeface="Arial"/>
+              </a:rPr>
+              <a:t>•  Clear messages for bad files or no defects</a:t>
             </a:r>
           </a:p>
         </p:txBody>
@@ -11848,7 +12264,7 @@
                 </a:solidFill>
                 <a:latin typeface="Arial"/>
               </a:rPr>
-              <a:t>Conclusion and future work</a:t>
+              <a:t>Limitations</a:t>
             </a:r>
           </a:p>
         </p:txBody>
@@ -11982,8 +12398,8 @@
         </p:nvSpPr>
         <p:spPr>
           <a:xfrm>
-            <a:off x="548640" y="1371600"/>
-            <a:ext cx="4572000" cy="457200"/>
+            <a:off x="548640" y="1463040"/>
+            <a:ext cx="10972800" cy="4572000"/>
           </a:xfrm>
           <a:prstGeom prst="rect">
             <a:avLst/>
@@ -12002,38 +12418,15 @@
               </a:spcAft>
             </a:pPr>
             <a:r>
-              <a:rPr sz="1600" b="1">
-                <a:solidFill>
-                  <a:srgbClr val="2E7D32"/>
+              <a:rPr sz="1800" b="0">
+                <a:solidFill>
+                  <a:srgbClr val="1F2933"/>
                 </a:solidFill>
                 <a:latin typeface="Arial"/>
               </a:rPr>
-              <a:t>Findings</a:t>
-            </a:r>
-          </a:p>
-        </p:txBody>
-      </p:sp>
-      <p:sp>
-        <p:nvSpPr>
-          <p:cNvPr id="7" name="TextBox 6"/>
-          <p:cNvSpPr txBox="1"/>
-          <p:nvPr/>
-        </p:nvSpPr>
-        <p:spPr>
-          <a:xfrm>
-            <a:off x="548640" y="1828800"/>
-            <a:ext cx="5486400" cy="4206240"/>
-          </a:xfrm>
-          <a:prstGeom prst="rect">
-            <a:avLst/>
-          </a:prstGeom>
-          <a:noFill/>
-        </p:spPr>
-        <p:txBody>
-          <a:bodyPr wrap="square" anchor="t">
-            <a:spAutoFit/>
-          </a:bodyPr>
-          <a:lstStyle/>
+              <a:t>•  Labels describe appearance only. The model does not diagnose disease or internal damage</a:t>
+            </a:r>
+          </a:p>
           <a:p>
             <a:pPr algn="l">
               <a:spcAft>
@@ -12041,13 +12434,13 @@
               </a:spcAft>
             </a:pPr>
             <a:r>
-              <a:rPr sz="1700" b="0">
+              <a:rPr sz="1800" b="0">
                 <a:solidFill>
                   <a:srgbClr val="1F2933"/>
                 </a:solidFill>
                 <a:latin typeface="Arial"/>
               </a:rPr>
-              <a:t>•  Two-stage YOLO26l segments the whole apple almost perfectly</a:t>
+              <a:t>•  Few image sources with mostly plain backgrounds</a:t>
             </a:r>
           </a:p>
           <a:p>
@@ -12057,13 +12450,13 @@
               </a:spcAft>
             </a:pPr>
             <a:r>
-              <a:rPr sz="1700" b="0">
+              <a:rPr sz="1800" b="0">
                 <a:solidFill>
                   <a:srgbClr val="1F2933"/>
                 </a:solidFill>
                 <a:latin typeface="Arial"/>
               </a:rPr>
-              <a:t>•  Defects reach 0.688 validation and 0.613 test mask mAP50</a:t>
+              <a:t>•  Small surface damage remains hard and lowers recall</a:t>
             </a:r>
           </a:p>
           <a:p>
@@ -12073,13 +12466,13 @@
               </a:spcAft>
             </a:pPr>
             <a:r>
-              <a:rPr sz="1700" b="0">
+              <a:rPr sz="1800" b="0">
                 <a:solidFill>
                   <a:srgbClr val="1F2933"/>
                 </a:solidFill>
                 <a:latin typeface="Arial"/>
               </a:rPr>
-              <a:t>•  Rot is the most stable class and surface damage the hardest</a:t>
+              <a:t>•  Two-stage gain is not isolated from model size and settings</a:t>
             </a:r>
           </a:p>
           <a:p>
@@ -12089,38 +12482,15 @@
               </a:spcAft>
             </a:pPr>
             <a:r>
-              <a:rPr sz="1700" b="0">
+              <a:rPr sz="1800" b="0">
                 <a:solidFill>
                   <a:srgbClr val="1F2933"/>
                 </a:solidFill>
                 <a:latin typeface="Arial"/>
               </a:rPr>
-              <a:t>•  Working upload app for apple and tomato</a:t>
-            </a:r>
-          </a:p>
-        </p:txBody>
-      </p:sp>
-      <p:sp>
-        <p:nvSpPr>
-          <p:cNvPr id="8" name="TextBox 7"/>
-          <p:cNvSpPr txBox="1"/>
-          <p:nvPr/>
-        </p:nvSpPr>
-        <p:spPr>
-          <a:xfrm>
-            <a:off x="6309360" y="1828800"/>
-            <a:ext cx="5394960" cy="4206240"/>
-          </a:xfrm>
-          <a:prstGeom prst="rect">
-            <a:avLst/>
-          </a:prstGeom>
-          <a:noFill/>
-        </p:spPr>
-        <p:txBody>
-          <a:bodyPr wrap="square" anchor="t">
-            <a:spAutoFit/>
-          </a:bodyPr>
-          <a:lstStyle/>
+              <a:t>•  Repeated Lab2Wild views of one apple crossed splits. Clean test mAP50 is 0.504</a:t>
+            </a:r>
+          </a:p>
           <a:p>
             <a:pPr algn="l">
               <a:spcAft>
@@ -12128,100 +12498,13 @@
               </a:spcAft>
             </a:pPr>
             <a:r>
-              <a:rPr sz="1700" b="0">
+              <a:rPr sz="1800" b="0">
                 <a:solidFill>
                   <a:srgbClr val="1F2933"/>
                 </a:solidFill>
                 <a:latin typeface="Arial"/>
               </a:rPr>
-              <a:t>•  More small-defect examples</a:t>
-            </a:r>
-          </a:p>
-          <a:p>
-            <a:pPr algn="l">
-              <a:spcAft>
-                <a:spcPts val="800"/>
-              </a:spcAft>
-            </a:pPr>
-            <a:r>
-              <a:rPr sz="1700" b="0">
-                <a:solidFill>
-                  <a:srgbClr val="1F2933"/>
-                </a:solidFill>
-                <a:latin typeface="Arial"/>
-              </a:rPr>
-              <a:t>•  Controlled single-stage baseline with equal settings</a:t>
-            </a:r>
-          </a:p>
-          <a:p>
-            <a:pPr algn="l">
-              <a:spcAft>
-                <a:spcPts val="800"/>
-              </a:spcAft>
-            </a:pPr>
-            <a:r>
-              <a:rPr sz="1700" b="0">
-                <a:solidFill>
-                  <a:srgbClr val="1F2933"/>
-                </a:solidFill>
-                <a:latin typeface="Arial"/>
-              </a:rPr>
-              <a:t>•  Test on new sources and lighting</a:t>
-            </a:r>
-          </a:p>
-          <a:p>
-            <a:pPr algn="l">
-              <a:spcAft>
-                <a:spcPts val="800"/>
-              </a:spcAft>
-            </a:pPr>
-            <a:r>
-              <a:rPr sz="1700" b="0">
-                <a:solidFill>
-                  <a:srgbClr val="1F2933"/>
-                </a:solidFill>
-                <a:latin typeface="Arial"/>
-              </a:rPr>
-              <a:t>•  Measure agreement between annotators</a:t>
-            </a:r>
-          </a:p>
-        </p:txBody>
-      </p:sp>
-      <p:sp>
-        <p:nvSpPr>
-          <p:cNvPr id="9" name="TextBox 8"/>
-          <p:cNvSpPr txBox="1"/>
-          <p:nvPr/>
-        </p:nvSpPr>
-        <p:spPr>
-          <a:xfrm>
-            <a:off x="6309360" y="1371600"/>
-            <a:ext cx="4572000" cy="457200"/>
-          </a:xfrm>
-          <a:prstGeom prst="rect">
-            <a:avLst/>
-          </a:prstGeom>
-          <a:noFill/>
-        </p:spPr>
-        <p:txBody>
-          <a:bodyPr wrap="square" anchor="t">
-            <a:spAutoFit/>
-          </a:bodyPr>
-          <a:lstStyle/>
-          <a:p>
-            <a:pPr algn="l">
-              <a:spcAft>
-                <a:spcPts val="800"/>
-              </a:spcAft>
-            </a:pPr>
-            <a:r>
-              <a:rPr sz="1600" b="1">
-                <a:solidFill>
-                  <a:srgbClr val="2E7D32"/>
-                </a:solidFill>
-                <a:latin typeface="Arial"/>
-              </a:rPr>
-              <a:t>Next steps</a:t>
+              <a:t>•  One annotator per image with review. No formal agreement score yet</a:t>
             </a:r>
           </a:p>
         </p:txBody>
@@ -12278,7 +12561,7 @@
                 </a:solidFill>
                 <a:latin typeface="Arial"/>
               </a:rPr>
-              <a:t>References and AI disclosure</a:t>
+              <a:t>Conclusion and future work</a:t>
             </a:r>
           </a:p>
         </p:txBody>
@@ -12400,6 +12683,452 @@
                 <a:latin typeface="Arial"/>
               </a:rPr>
               <a:t>23</a:t>
+            </a:r>
+          </a:p>
+        </p:txBody>
+      </p:sp>
+      <p:sp>
+        <p:nvSpPr>
+          <p:cNvPr id="6" name="TextBox 5"/>
+          <p:cNvSpPr txBox="1"/>
+          <p:nvPr/>
+        </p:nvSpPr>
+        <p:spPr>
+          <a:xfrm>
+            <a:off x="548640" y="1371600"/>
+            <a:ext cx="4572000" cy="457200"/>
+          </a:xfrm>
+          <a:prstGeom prst="rect">
+            <a:avLst/>
+          </a:prstGeom>
+          <a:noFill/>
+        </p:spPr>
+        <p:txBody>
+          <a:bodyPr wrap="square" anchor="t">
+            <a:spAutoFit/>
+          </a:bodyPr>
+          <a:lstStyle/>
+          <a:p>
+            <a:pPr algn="l">
+              <a:spcAft>
+                <a:spcPts val="800"/>
+              </a:spcAft>
+            </a:pPr>
+            <a:r>
+              <a:rPr sz="1600" b="1">
+                <a:solidFill>
+                  <a:srgbClr val="2E7D32"/>
+                </a:solidFill>
+                <a:latin typeface="Arial"/>
+              </a:rPr>
+              <a:t>Findings</a:t>
+            </a:r>
+          </a:p>
+        </p:txBody>
+      </p:sp>
+      <p:sp>
+        <p:nvSpPr>
+          <p:cNvPr id="7" name="TextBox 6"/>
+          <p:cNvSpPr txBox="1"/>
+          <p:nvPr/>
+        </p:nvSpPr>
+        <p:spPr>
+          <a:xfrm>
+            <a:off x="548640" y="1828800"/>
+            <a:ext cx="5486400" cy="4206240"/>
+          </a:xfrm>
+          <a:prstGeom prst="rect">
+            <a:avLst/>
+          </a:prstGeom>
+          <a:noFill/>
+        </p:spPr>
+        <p:txBody>
+          <a:bodyPr wrap="square" anchor="t">
+            <a:spAutoFit/>
+          </a:bodyPr>
+          <a:lstStyle/>
+          <a:p>
+            <a:pPr algn="l">
+              <a:spcAft>
+                <a:spcPts val="800"/>
+              </a:spcAft>
+            </a:pPr>
+            <a:r>
+              <a:rPr sz="1700" b="0">
+                <a:solidFill>
+                  <a:srgbClr val="1F2933"/>
+                </a:solidFill>
+                <a:latin typeface="Arial"/>
+              </a:rPr>
+              <a:t>•  Two-stage YOLO26l segments the whole apple almost perfectly</a:t>
+            </a:r>
+          </a:p>
+          <a:p>
+            <a:pPr algn="l">
+              <a:spcAft>
+                <a:spcPts val="800"/>
+              </a:spcAft>
+            </a:pPr>
+            <a:r>
+              <a:rPr sz="1700" b="0">
+                <a:solidFill>
+                  <a:srgbClr val="1F2933"/>
+                </a:solidFill>
+                <a:latin typeface="Arial"/>
+              </a:rPr>
+              <a:t>•  Defects reach 0.613 test mask mAP50 and 0.504 without near-duplicates</a:t>
+            </a:r>
+          </a:p>
+          <a:p>
+            <a:pPr algn="l">
+              <a:spcAft>
+                <a:spcPts val="800"/>
+              </a:spcAft>
+            </a:pPr>
+            <a:r>
+              <a:rPr sz="1700" b="0">
+                <a:solidFill>
+                  <a:srgbClr val="1F2933"/>
+                </a:solidFill>
+                <a:latin typeface="Arial"/>
+              </a:rPr>
+              <a:t>•  Rot is the most stable class and surface damage the hardest</a:t>
+            </a:r>
+          </a:p>
+          <a:p>
+            <a:pPr algn="l">
+              <a:spcAft>
+                <a:spcPts val="800"/>
+              </a:spcAft>
+            </a:pPr>
+            <a:r>
+              <a:rPr sz="1700" b="0">
+                <a:solidFill>
+                  <a:srgbClr val="1F2933"/>
+                </a:solidFill>
+                <a:latin typeface="Arial"/>
+              </a:rPr>
+              <a:t>•  Working upload app for apple and tomato</a:t>
+            </a:r>
+          </a:p>
+        </p:txBody>
+      </p:sp>
+      <p:sp>
+        <p:nvSpPr>
+          <p:cNvPr id="8" name="TextBox 7"/>
+          <p:cNvSpPr txBox="1"/>
+          <p:nvPr/>
+        </p:nvSpPr>
+        <p:spPr>
+          <a:xfrm>
+            <a:off x="6309360" y="1828800"/>
+            <a:ext cx="5394960" cy="4206240"/>
+          </a:xfrm>
+          <a:prstGeom prst="rect">
+            <a:avLst/>
+          </a:prstGeom>
+          <a:noFill/>
+        </p:spPr>
+        <p:txBody>
+          <a:bodyPr wrap="square" anchor="t">
+            <a:spAutoFit/>
+          </a:bodyPr>
+          <a:lstStyle/>
+          <a:p>
+            <a:pPr algn="l">
+              <a:spcAft>
+                <a:spcPts val="800"/>
+              </a:spcAft>
+            </a:pPr>
+            <a:r>
+              <a:rPr sz="1700" b="0">
+                <a:solidFill>
+                  <a:srgbClr val="1F2933"/>
+                </a:solidFill>
+                <a:latin typeface="Arial"/>
+              </a:rPr>
+              <a:t>•  Group by image similarity before splitting</a:t>
+            </a:r>
+          </a:p>
+          <a:p>
+            <a:pPr algn="l">
+              <a:spcAft>
+                <a:spcPts val="800"/>
+              </a:spcAft>
+            </a:pPr>
+            <a:r>
+              <a:rPr sz="1700" b="0">
+                <a:solidFill>
+                  <a:srgbClr val="1F2933"/>
+                </a:solidFill>
+                <a:latin typeface="Arial"/>
+              </a:rPr>
+              <a:t>•  More small-defect examples</a:t>
+            </a:r>
+          </a:p>
+          <a:p>
+            <a:pPr algn="l">
+              <a:spcAft>
+                <a:spcPts val="800"/>
+              </a:spcAft>
+            </a:pPr>
+            <a:r>
+              <a:rPr sz="1700" b="0">
+                <a:solidFill>
+                  <a:srgbClr val="1F2933"/>
+                </a:solidFill>
+                <a:latin typeface="Arial"/>
+              </a:rPr>
+              <a:t>•  Controlled single-stage baseline with equal settings</a:t>
+            </a:r>
+          </a:p>
+          <a:p>
+            <a:pPr algn="l">
+              <a:spcAft>
+                <a:spcPts val="800"/>
+              </a:spcAft>
+            </a:pPr>
+            <a:r>
+              <a:rPr sz="1700" b="0">
+                <a:solidFill>
+                  <a:srgbClr val="1F2933"/>
+                </a:solidFill>
+                <a:latin typeface="Arial"/>
+              </a:rPr>
+              <a:t>•  Test on new sources and lighting</a:t>
+            </a:r>
+          </a:p>
+          <a:p>
+            <a:pPr algn="l">
+              <a:spcAft>
+                <a:spcPts val="800"/>
+              </a:spcAft>
+            </a:pPr>
+            <a:r>
+              <a:rPr sz="1700" b="0">
+                <a:solidFill>
+                  <a:srgbClr val="1F2933"/>
+                </a:solidFill>
+                <a:latin typeface="Arial"/>
+              </a:rPr>
+              <a:t>•  Measure agreement between annotators</a:t>
+            </a:r>
+          </a:p>
+        </p:txBody>
+      </p:sp>
+      <p:sp>
+        <p:nvSpPr>
+          <p:cNvPr id="9" name="TextBox 8"/>
+          <p:cNvSpPr txBox="1"/>
+          <p:nvPr/>
+        </p:nvSpPr>
+        <p:spPr>
+          <a:xfrm>
+            <a:off x="6309360" y="1371600"/>
+            <a:ext cx="4572000" cy="457200"/>
+          </a:xfrm>
+          <a:prstGeom prst="rect">
+            <a:avLst/>
+          </a:prstGeom>
+          <a:noFill/>
+        </p:spPr>
+        <p:txBody>
+          <a:bodyPr wrap="square" anchor="t">
+            <a:spAutoFit/>
+          </a:bodyPr>
+          <a:lstStyle/>
+          <a:p>
+            <a:pPr algn="l">
+              <a:spcAft>
+                <a:spcPts val="800"/>
+              </a:spcAft>
+            </a:pPr>
+            <a:r>
+              <a:rPr sz="1600" b="1">
+                <a:solidFill>
+                  <a:srgbClr val="2E7D32"/>
+                </a:solidFill>
+                <a:latin typeface="Arial"/>
+              </a:rPr>
+              <a:t>Next steps</a:t>
+            </a:r>
+          </a:p>
+        </p:txBody>
+      </p:sp>
+    </p:spTree>
+  </p:cSld>
+  <p:clrMapOvr>
+    <a:masterClrMapping/>
+  </p:clrMapOvr>
+</p:sld>
+</file>
+
+<file path=ppt/slides/slide24.xml><?xml version="1.0" encoding="utf-8"?>
+<p:sld xmlns:a="http://schemas.openxmlformats.org/drawingml/2006/main" xmlns:p="http://schemas.openxmlformats.org/presentationml/2006/main" xmlns:r="http://schemas.openxmlformats.org/officeDocument/2006/relationships">
+  <p:cSld>
+    <p:spTree>
+      <p:nvGrpSpPr>
+        <p:cNvPr id="1" name=""/>
+        <p:cNvGrpSpPr/>
+        <p:nvPr/>
+      </p:nvGrpSpPr>
+      <p:grpSpPr/>
+      <p:sp>
+        <p:nvSpPr>
+          <p:cNvPr id="2" name="TextBox 1"/>
+          <p:cNvSpPr txBox="1"/>
+          <p:nvPr/>
+        </p:nvSpPr>
+        <p:spPr>
+          <a:xfrm>
+            <a:off x="548640" y="320040"/>
+            <a:ext cx="10972800" cy="731520"/>
+          </a:xfrm>
+          <a:prstGeom prst="rect">
+            <a:avLst/>
+          </a:prstGeom>
+          <a:noFill/>
+        </p:spPr>
+        <p:txBody>
+          <a:bodyPr wrap="square" anchor="t">
+            <a:spAutoFit/>
+          </a:bodyPr>
+          <a:lstStyle/>
+          <a:p>
+            <a:pPr algn="l">
+              <a:spcAft>
+                <a:spcPts val="800"/>
+              </a:spcAft>
+            </a:pPr>
+            <a:r>
+              <a:rPr sz="2800" b="1">
+                <a:solidFill>
+                  <a:srgbClr val="1F2933"/>
+                </a:solidFill>
+                <a:latin typeface="Arial"/>
+              </a:rPr>
+              <a:t>References and AI disclosure</a:t>
+            </a:r>
+          </a:p>
+        </p:txBody>
+      </p:sp>
+      <p:sp>
+        <p:nvSpPr>
+          <p:cNvPr id="3" name="Rectangle 2"/>
+          <p:cNvSpPr/>
+          <p:nvPr/>
+        </p:nvSpPr>
+        <p:spPr>
+          <a:xfrm>
+            <a:off x="548640" y="1024128"/>
+            <a:ext cx="1097280" cy="54864"/>
+          </a:xfrm>
+          <a:prstGeom prst="rect">
+            <a:avLst/>
+          </a:prstGeom>
+          <a:solidFill>
+            <a:srgbClr val="2E7D32"/>
+          </a:solidFill>
+          <a:ln>
+            <a:noFill/>
+          </a:ln>
+        </p:spPr>
+        <p:style>
+          <a:lnRef idx="1">
+            <a:schemeClr val="accent1"/>
+          </a:lnRef>
+          <a:fillRef idx="3">
+            <a:schemeClr val="accent1"/>
+          </a:fillRef>
+          <a:effectRef idx="2">
+            <a:schemeClr val="accent1"/>
+          </a:effectRef>
+          <a:fontRef idx="minor">
+            <a:schemeClr val="lt1"/>
+          </a:fontRef>
+        </p:style>
+        <p:txBody>
+          <a:bodyPr rtlCol="0" anchor="ctr"/>
+          <a:lstStyle/>
+          <a:p>
+            <a:pPr algn="ctr"/>
+          </a:p>
+        </p:txBody>
+      </p:sp>
+      <p:sp>
+        <p:nvSpPr>
+          <p:cNvPr id="4" name="TextBox 3"/>
+          <p:cNvSpPr txBox="1"/>
+          <p:nvPr/>
+        </p:nvSpPr>
+        <p:spPr>
+          <a:xfrm>
+            <a:off x="548640" y="6400800"/>
+            <a:ext cx="7315200" cy="320040"/>
+          </a:xfrm>
+          <a:prstGeom prst="rect">
+            <a:avLst/>
+          </a:prstGeom>
+          <a:noFill/>
+        </p:spPr>
+        <p:txBody>
+          <a:bodyPr wrap="square" anchor="t">
+            <a:spAutoFit/>
+          </a:bodyPr>
+          <a:lstStyle/>
+          <a:p>
+            <a:pPr algn="l">
+              <a:spcAft>
+                <a:spcPts val="800"/>
+              </a:spcAft>
+            </a:pPr>
+            <a:r>
+              <a:rPr sz="1000" b="0">
+                <a:solidFill>
+                  <a:srgbClr val="52606D"/>
+                </a:solidFill>
+                <a:latin typeface="Arial"/>
+              </a:rPr>
+              <a:t>CIPHER  |  AI2 AM3  |  Fruit Defect Segmentation</a:t>
+            </a:r>
+          </a:p>
+        </p:txBody>
+      </p:sp>
+      <p:sp>
+        <p:nvSpPr>
+          <p:cNvPr id="5" name="TextBox 4"/>
+          <p:cNvSpPr txBox="1"/>
+          <p:nvPr/>
+        </p:nvSpPr>
+        <p:spPr>
+          <a:xfrm>
+            <a:off x="10881360" y="6400800"/>
+            <a:ext cx="822960" cy="320040"/>
+          </a:xfrm>
+          <a:prstGeom prst="rect">
+            <a:avLst/>
+          </a:prstGeom>
+          <a:noFill/>
+        </p:spPr>
+        <p:txBody>
+          <a:bodyPr wrap="square" anchor="t">
+            <a:spAutoFit/>
+          </a:bodyPr>
+          <a:lstStyle/>
+          <a:p>
+            <a:pPr algn="r">
+              <a:spcAft>
+                <a:spcPts val="800"/>
+              </a:spcAft>
+            </a:pPr>
+            <a:r>
+              <a:rPr sz="1000" b="0">
+                <a:solidFill>
+                  <a:srgbClr val="52606D"/>
+                </a:solidFill>
+                <a:latin typeface="Arial"/>
+              </a:rPr>
+              <a:t>24</a:t>
             </a:r>
           </a:p>
         </p:txBody>
@@ -15294,7 +16023,23 @@
                 </a:solidFill>
                 <a:latin typeface="Arial"/>
               </a:rPr>
-              <a:t>•  Exact pixel hashes checked across splits: no overlap</a:t>
+              <a:t>•  Exact pixel hashes checked across splits: no exact copies</a:t>
+            </a:r>
+          </a:p>
+          <a:p>
+            <a:pPr algn="l">
+              <a:spcAft>
+                <a:spcPts val="800"/>
+              </a:spcAft>
+            </a:pPr>
+            <a:r>
+              <a:rPr sz="1600" b="0">
+                <a:solidFill>
+                  <a:srgbClr val="1F2933"/>
+                </a:solidFill>
+                <a:latin typeface="Arial"/>
+              </a:rPr>
+              <a:t>•  Later check found near-copies of Lab2Wild apples across splits (see leakage slide)</a:t>
             </a:r>
           </a:p>
           <a:p>

</xml_diff>